<commit_message>
Flywheel hero image + opening deck slide
pitch/flywheel.html — deck-red SVG flywheel: Armchair Experts (The NFL in
Australia) centre, six-node loop (weekly show, Cali to the G, social,
website, Watch on Disney+, data & attribution) with clockwise arrows and
the neon ripple motif; captured to pitch/assets/flywheel.png via the
headless-Chrome pipeline and added as the full-bleed opening slide.

Co-Authored-By: Claude Fable 5 <noreply@anthropic.com>
</commit_message>
<xml_diff>
--- a/pitch/Armchair-Disney-slides.pptx
+++ b/pitch/Armchair-Disney-slides.pptx
@@ -8,9 +8,10 @@
     <p:sldId id="256" r:id="rId2"/>
     <p:sldId id="257" r:id="rId3"/>
     <p:sldId id="258" r:id="rId4"/>
+    <p:sldId id="259" r:id="rId5"/>
   </p:sldIdLst>
   <p:notesMasterIdLst>
-    <p:notesMasterId r:id="rId5"/>
+    <p:notesMasterId r:id="rId6"/>
   </p:notesMasterIdLst>
   <p:sldSz cx="12188952" cy="6858000"/>
   <p:notesSz cx="6858000" cy="12188952"/>
@@ -704,6 +705,94 @@
             <a:fld id="{F7021451-1387-4CA6-816F-3879F97B5CBC}" type="slidenum">
               <a:rPr lang="en-US"/>
               <a:t>3</a:t>
+            </a:fld>
+            <a:endParaRPr lang="en-US"/>
+          </a:p>
+        </p:txBody>
+      </p:sp>
+    </p:spTree>
+    <p:extLst>
+      <p:ext uri="{BB962C8B-B14F-4D97-AF65-F5344CB8AC3E}">
+        <p14:creationId xmlns:p14="http://schemas.microsoft.com/office/powerpoint/2010/main" val="1024086991"/>
+      </p:ext>
+    </p:extLst>
+  </p:cSld>
+  <p:clrMapOvr>
+    <a:masterClrMapping/>
+  </p:clrMapOvr>
+</p:notes>
+</file>
+
+<file path=ppt/notesSlides/notesSlide4.xml><?xml version="1.0" encoding="utf-8"?>
+<p:notes xmlns:a="http://schemas.openxmlformats.org/drawingml/2006/main" xmlns:r="http://schemas.openxmlformats.org/officeDocument/2006/relationships" xmlns:p="http://schemas.openxmlformats.org/presentationml/2006/main">
+  <p:cSld>
+    <p:spTree>
+      <p:nvGrpSpPr>
+        <p:cNvPr id="1" name=""/>
+        <p:cNvGrpSpPr/>
+        <p:nvPr/>
+      </p:nvGrpSpPr>
+      <p:grpSpPr>
+        <a:xfrm>
+          <a:off x="0" y="0"/>
+          <a:ext cx="0" cy="0"/>
+          <a:chOff x="0" y="0"/>
+          <a:chExt cx="0" cy="0"/>
+        </a:xfrm>
+      </p:grpSpPr>
+      <p:sp>
+        <p:nvSpPr>
+          <p:cNvPr id="2" name="Slide Image Placeholder 1"/>
+          <p:cNvSpPr>
+            <a:spLocks noGrp="1" noRot="1" noChangeAspect="1"/>
+          </p:cNvSpPr>
+          <p:nvPr>
+            <p:ph type="sldImg"/>
+          </p:nvPr>
+        </p:nvSpPr>
+        <p:spPr/>
+      </p:sp>
+      <p:sp>
+        <p:nvSpPr>
+          <p:cNvPr id="3" name="Notes Placeholder 2"/>
+          <p:cNvSpPr>
+            <a:spLocks noGrp="1"/>
+          </p:cNvSpPr>
+          <p:nvPr>
+            <p:ph type="body" idx="1"/>
+          </p:nvPr>
+        </p:nvSpPr>
+        <p:spPr/>
+        <p:txBody>
+          <a:bodyPr/>
+          <a:lstStyle/>
+          <a:p>
+            <a:r>
+              <a:rPr lang="en-US" dirty="0"/>
+              <a:t/>
+            </a:r>
+            <a:endParaRPr lang="en-US" dirty="0"/>
+          </a:p>
+        </p:txBody>
+      </p:sp>
+      <p:sp>
+        <p:nvSpPr>
+          <p:cNvPr id="4" name="Slide Number Placeholder 3"/>
+          <p:cNvSpPr>
+            <a:spLocks noGrp="1"/>
+          </p:cNvSpPr>
+          <p:nvPr>
+            <p:ph type="sldNum" sz="quarter" idx="10"/>
+          </p:nvPr>
+        </p:nvSpPr>
+        <p:spPr/>
+        <p:txBody>
+          <a:bodyPr/>
+          <a:lstStyle/>
+          <a:p>
+            <a:fld id="{F7021451-1387-4CA6-816F-3879F97B5CBC}" type="slidenum">
+              <a:rPr lang="en-US"/>
+              <a:t>4</a:t>
             </a:fld>
             <a:endParaRPr lang="en-US"/>
           </a:p>
@@ -1053,1047 +1142,30 @@
           <a:chExt cx="0" cy="0"/>
         </a:xfrm>
       </p:grpSpPr>
-      <p:sp>
-        <p:nvSpPr>
-          <p:cNvPr id="2" name="Text 0"/>
-          <p:cNvSpPr/>
-          <p:nvPr/>
-        </p:nvSpPr>
-        <p:spPr>
-          <a:xfrm>
-            <a:off x="8074152" y="384048"/>
-            <a:ext cx="3657600" cy="274320"/>
-          </a:xfrm>
-          <a:prstGeom prst="rect">
-            <a:avLst/>
-          </a:prstGeom>
-          <a:noFill/>
-          <a:ln/>
-        </p:spPr>
-        <p:txBody>
-          <a:bodyPr wrap="square" lIns="0" tIns="0" rIns="0" bIns="0" rtlCol="0" anchor="ctr"/>
-          <a:lstStyle/>
-          <a:p>
-            <a:pPr algn="r" indent="0" marL="0">
-              <a:buNone/>
-            </a:pPr>
-            <a:r>
-              <a:rPr lang="en-US" sz="1400" b="1" dirty="0">
-                <a:solidFill>
-                  <a:srgbClr val="F9F3F5"/>
-                </a:solidFill>
-                <a:latin typeface="Arial Narrow" pitchFamily="34" charset="0"/>
-                <a:ea typeface="Arial Narrow" pitchFamily="34" charset="-122"/>
-                <a:cs typeface="Arial Narrow" pitchFamily="34" charset="-120"/>
-              </a:rPr>
-              <a:t>Armchair</a:t>
-            </a:r>
-            <a:pPr algn="r" indent="0" marL="0">
-              <a:buNone/>
-            </a:pPr>
-            <a:r>
-              <a:rPr lang="en-US" sz="1400" b="1" dirty="0">
-                <a:solidFill>
-                  <a:srgbClr val="F5294B"/>
-                </a:solidFill>
-                <a:latin typeface="Arial Narrow" pitchFamily="34" charset="0"/>
-                <a:ea typeface="Arial Narrow" pitchFamily="34" charset="-122"/>
-                <a:cs typeface="Arial Narrow" pitchFamily="34" charset="-120"/>
-              </a:rPr>
-              <a:t>·</a:t>
-            </a:r>
-            <a:pPr algn="r" indent="0" marL="0">
-              <a:buNone/>
-            </a:pPr>
-            <a:r>
-              <a:rPr lang="en-US" sz="1400" b="1" dirty="0">
-                <a:solidFill>
-                  <a:srgbClr val="F9F3F5"/>
-                </a:solidFill>
-                <a:latin typeface="Arial Narrow" pitchFamily="34" charset="0"/>
-                <a:ea typeface="Arial Narrow" pitchFamily="34" charset="-122"/>
-                <a:cs typeface="Arial Narrow" pitchFamily="34" charset="-120"/>
-              </a:rPr>
-              <a:t>Experts</a:t>
-            </a:r>
-            <a:endParaRPr lang="en-US" sz="1400" dirty="0"/>
-          </a:p>
-        </p:txBody>
-      </p:sp>
-      <p:sp>
-        <p:nvSpPr>
-          <p:cNvPr id="3" name="Text 1"/>
-          <p:cNvSpPr/>
-          <p:nvPr/>
-        </p:nvSpPr>
-        <p:spPr>
-          <a:xfrm>
-            <a:off x="8074152" y="676656"/>
-            <a:ext cx="3657600" cy="228600"/>
-          </a:xfrm>
-          <a:prstGeom prst="rect">
-            <a:avLst/>
-          </a:prstGeom>
-          <a:noFill/>
-          <a:ln/>
-        </p:spPr>
-        <p:txBody>
-          <a:bodyPr wrap="square" lIns="0" tIns="0" rIns="0" bIns="0" rtlCol="0" anchor="ctr"/>
-          <a:lstStyle/>
-          <a:p>
-            <a:pPr algn="r" indent="0" marL="0">
-              <a:buNone/>
-            </a:pPr>
-            <a:r>
-              <a:rPr lang="en-US" sz="950" spc="100" kern="0" dirty="0">
-                <a:solidFill>
-                  <a:srgbClr val="A57E8B"/>
-                </a:solidFill>
-                <a:latin typeface="Arial" pitchFamily="34" charset="0"/>
-                <a:ea typeface="Arial" pitchFamily="34" charset="-122"/>
-                <a:cs typeface="Arial" pitchFamily="34" charset="-120"/>
-              </a:rPr>
-              <a:t>STREAMING PARTNER · </a:t>
-            </a:r>
-            <a:pPr algn="r" indent="0" marL="0">
-              <a:buNone/>
-            </a:pPr>
-            <a:r>
-              <a:rPr lang="en-US" sz="950" b="1" spc="100" kern="0" dirty="0">
-                <a:solidFill>
-                  <a:srgbClr val="5AA7FF"/>
-                </a:solidFill>
-                <a:latin typeface="Arial" pitchFamily="34" charset="0"/>
-                <a:ea typeface="Arial" pitchFamily="34" charset="-122"/>
-                <a:cs typeface="Arial" pitchFamily="34" charset="-120"/>
-              </a:rPr>
-              <a:t>Disney+</a:t>
-            </a:r>
-            <a:endParaRPr lang="en-US" sz="950" dirty="0"/>
-          </a:p>
-        </p:txBody>
-      </p:sp>
-      <p:sp>
-        <p:nvSpPr>
-          <p:cNvPr id="4" name="Text 2"/>
-          <p:cNvSpPr/>
-          <p:nvPr/>
-        </p:nvSpPr>
-        <p:spPr>
-          <a:xfrm>
-            <a:off x="457200" y="457200"/>
-            <a:ext cx="7315200" cy="274320"/>
-          </a:xfrm>
-          <a:prstGeom prst="rect">
-            <a:avLst/>
-          </a:prstGeom>
-          <a:noFill/>
-          <a:ln/>
-        </p:spPr>
-        <p:txBody>
-          <a:bodyPr wrap="square" lIns="0" tIns="0" rIns="0" bIns="0" rtlCol="0" anchor="ctr"/>
-          <a:lstStyle/>
-          <a:p>
-            <a:pPr indent="0" marL="0">
-              <a:buNone/>
-            </a:pPr>
-            <a:r>
-              <a:rPr lang="en-US" sz="1100" b="1" spc="300" kern="0" dirty="0">
-                <a:solidFill>
-                  <a:srgbClr val="F5294B"/>
-                </a:solidFill>
-                <a:latin typeface="Arial" pitchFamily="34" charset="0"/>
-                <a:ea typeface="Arial" pitchFamily="34" charset="-122"/>
-                <a:cs typeface="Arial" pitchFamily="34" charset="-120"/>
-              </a:rPr>
-              <a:t>THE AUDIENCE</a:t>
-            </a:r>
-            <a:endParaRPr lang="en-US" sz="1100" dirty="0"/>
-          </a:p>
-        </p:txBody>
-      </p:sp>
-      <p:sp>
-        <p:nvSpPr>
-          <p:cNvPr id="5" name="Text 3"/>
-          <p:cNvSpPr/>
-          <p:nvPr/>
-        </p:nvSpPr>
-        <p:spPr>
-          <a:xfrm>
-            <a:off x="438912" y="749808"/>
-            <a:ext cx="8412480" cy="1143000"/>
-          </a:xfrm>
-          <a:prstGeom prst="rect">
-            <a:avLst/>
-          </a:prstGeom>
-          <a:noFill/>
-          <a:ln/>
-        </p:spPr>
-        <p:txBody>
-          <a:bodyPr wrap="square" lIns="0" tIns="0" rIns="0" bIns="0" rtlCol="0" anchor="t"/>
-          <a:lstStyle/>
-          <a:p>
-            <a:pPr indent="0" marL="0">
-              <a:lnSpc>
-                <a:spcPct val="95000"/>
-              </a:lnSpc>
-              <a:buNone/>
-            </a:pPr>
-            <a:r>
-              <a:rPr lang="en-US" sz="4100" b="1" dirty="0">
-                <a:solidFill>
-                  <a:srgbClr val="F9F3F5"/>
-                </a:solidFill>
-                <a:latin typeface="Arial Narrow" pitchFamily="34" charset="0"/>
-                <a:ea typeface="Arial Narrow" pitchFamily="34" charset="-122"/>
-                <a:cs typeface="Arial Narrow" pitchFamily="34" charset="-120"/>
-              </a:rPr>
-              <a:t>Who Disney+ is really buying</a:t>
-            </a:r>
-            <a:endParaRPr lang="en-US" sz="4100" dirty="0"/>
-          </a:p>
-        </p:txBody>
-      </p:sp>
-      <p:sp>
-        <p:nvSpPr>
-          <p:cNvPr id="6" name="Text 4"/>
-          <p:cNvSpPr/>
-          <p:nvPr/>
-        </p:nvSpPr>
-        <p:spPr>
-          <a:xfrm>
-            <a:off x="457200" y="1938528"/>
-            <a:ext cx="7680960" cy="640080"/>
-          </a:xfrm>
-          <a:prstGeom prst="rect">
-            <a:avLst/>
-          </a:prstGeom>
-          <a:noFill/>
-          <a:ln/>
-        </p:spPr>
-        <p:txBody>
-          <a:bodyPr wrap="square" lIns="0" tIns="0" rIns="0" bIns="0" rtlCol="0" anchor="t"/>
-          <a:lstStyle/>
-          <a:p>
-            <a:pPr indent="0" marL="0">
-              <a:lnSpc>
-                <a:spcPct val="105000"/>
-              </a:lnSpc>
-              <a:buNone/>
-            </a:pPr>
-            <a:r>
-              <a:rPr lang="en-US" sz="1400" dirty="0">
-                <a:solidFill>
-                  <a:srgbClr val="DCC3CB"/>
-                </a:solidFill>
-                <a:latin typeface="Arial" pitchFamily="34" charset="0"/>
-                <a:ea typeface="Arial" pitchFamily="34" charset="-122"/>
-                <a:cs typeface="Arial" pitchFamily="34" charset="-120"/>
-              </a:rPr>
-              <a:t>Not impressions — a pre-qualified pool of streaming-ready NFL fans, indexed exactly where the league wants Australian growth.</a:t>
-            </a:r>
-            <a:endParaRPr lang="en-US" sz="1400" dirty="0"/>
-          </a:p>
-        </p:txBody>
-      </p:sp>
-      <p:sp>
-        <p:nvSpPr>
-          <p:cNvPr id="7" name="Shape 5"/>
-          <p:cNvSpPr/>
-          <p:nvPr/>
-        </p:nvSpPr>
-        <p:spPr>
-          <a:xfrm>
-            <a:off x="457200" y="2697480"/>
-            <a:ext cx="2695194" cy="1417320"/>
-          </a:xfrm>
-          <a:prstGeom prst="roundRect">
-            <a:avLst>
-              <a:gd name="adj" fmla="val 5806"/>
-            </a:avLst>
-          </a:prstGeom>
-          <a:solidFill>
-            <a:srgbClr val="1E0C13"/>
-          </a:solidFill>
-          <a:ln w="12700">
-            <a:solidFill>
-              <a:srgbClr val="43202C"/>
-            </a:solidFill>
-            <a:prstDash val="solid"/>
-          </a:ln>
-        </p:spPr>
-      </p:sp>
-      <p:sp>
-        <p:nvSpPr>
-          <p:cNvPr id="8" name="Text 6"/>
-          <p:cNvSpPr/>
-          <p:nvPr/>
-        </p:nvSpPr>
-        <p:spPr>
-          <a:xfrm>
-            <a:off x="603504" y="2825496"/>
-            <a:ext cx="2402586" cy="1161288"/>
-          </a:xfrm>
-          <a:prstGeom prst="rect">
-            <a:avLst/>
-          </a:prstGeom>
-          <a:noFill/>
-          <a:ln/>
-        </p:spPr>
-        <p:txBody>
-          <a:bodyPr wrap="square" lIns="0" tIns="0" rIns="0" bIns="0" rtlCol="0" anchor="t"/>
-          <a:lstStyle/>
-          <a:p>
-            <a:pPr indent="0" marL="0">
-              <a:lnSpc>
-                <a:spcPct val="98000"/>
-              </a:lnSpc>
-              <a:buNone/>
-            </a:pPr>
-            <a:r>
-              <a:rPr lang="en-US" sz="3400" b="1" dirty="0">
-                <a:solidFill>
-                  <a:srgbClr val="F5294B"/>
-                </a:solidFill>
-                <a:latin typeface="Arial Narrow" pitchFamily="34" charset="0"/>
-                <a:ea typeface="Arial Narrow" pitchFamily="34" charset="-122"/>
-                <a:cs typeface="Arial Narrow" pitchFamily="34" charset="-120"/>
-              </a:rPr>
-              <a:t>000k</a:t>
-            </a:r>
-            <a:endParaRPr lang="en-US" sz="3400" dirty="0"/>
-          </a:p>
-          <a:p>
-            <a:pPr indent="0" marL="0">
-              <a:lnSpc>
-                <a:spcPct val="98000"/>
-              </a:lnSpc>
-              <a:spcBef>
-                <a:spcPts val="600"/>
-              </a:spcBef>
-              <a:buNone/>
-            </a:pPr>
-            <a:r>
-              <a:rPr lang="en-US" sz="1250" b="1" dirty="0">
-                <a:solidFill>
-                  <a:srgbClr val="F9F3F5"/>
-                </a:solidFill>
-                <a:latin typeface="Arial" pitchFamily="34" charset="0"/>
-                <a:ea typeface="Arial" pitchFamily="34" charset="-122"/>
-                <a:cs typeface="Arial" pitchFamily="34" charset="-120"/>
-              </a:rPr>
-              <a:t>Monthly audience</a:t>
-            </a:r>
-            <a:endParaRPr lang="en-US" sz="3400" dirty="0"/>
-          </a:p>
-          <a:p>
-            <a:pPr indent="0" marL="0">
-              <a:lnSpc>
-                <a:spcPct val="98000"/>
-              </a:lnSpc>
-              <a:spcBef>
-                <a:spcPts val="300"/>
-              </a:spcBef>
-              <a:buNone/>
-            </a:pPr>
-            <a:r>
-              <a:rPr lang="en-US" sz="950" dirty="0">
-                <a:solidFill>
-                  <a:srgbClr val="A57E8B"/>
-                </a:solidFill>
-                <a:latin typeface="Arial" pitchFamily="34" charset="0"/>
-                <a:ea typeface="Arial" pitchFamily="34" charset="-122"/>
-                <a:cs typeface="Arial" pitchFamily="34" charset="-120"/>
-              </a:rPr>
-              <a:t>Across audio, video &amp; social</a:t>
-            </a:r>
-            <a:endParaRPr lang="en-US" sz="3400" dirty="0"/>
-          </a:p>
-        </p:txBody>
-      </p:sp>
-      <p:sp>
-        <p:nvSpPr>
-          <p:cNvPr id="9" name="Shape 7"/>
-          <p:cNvSpPr/>
-          <p:nvPr/>
-        </p:nvSpPr>
-        <p:spPr>
-          <a:xfrm>
-            <a:off x="3316986" y="2697480"/>
-            <a:ext cx="2695194" cy="1417320"/>
-          </a:xfrm>
-          <a:prstGeom prst="roundRect">
-            <a:avLst>
-              <a:gd name="adj" fmla="val 5806"/>
-            </a:avLst>
-          </a:prstGeom>
-          <a:solidFill>
-            <a:srgbClr val="1E0C13"/>
-          </a:solidFill>
-          <a:ln w="12700">
-            <a:solidFill>
-              <a:srgbClr val="43202C"/>
-            </a:solidFill>
-            <a:prstDash val="solid"/>
-          </a:ln>
-        </p:spPr>
-      </p:sp>
-      <p:sp>
-        <p:nvSpPr>
-          <p:cNvPr id="10" name="Text 8"/>
-          <p:cNvSpPr/>
-          <p:nvPr/>
-        </p:nvSpPr>
-        <p:spPr>
-          <a:xfrm>
-            <a:off x="3463290" y="2825496"/>
-            <a:ext cx="2402586" cy="1161288"/>
-          </a:xfrm>
-          <a:prstGeom prst="rect">
-            <a:avLst/>
-          </a:prstGeom>
-          <a:noFill/>
-          <a:ln/>
-        </p:spPr>
-        <p:txBody>
-          <a:bodyPr wrap="square" lIns="0" tIns="0" rIns="0" bIns="0" rtlCol="0" anchor="t"/>
-          <a:lstStyle/>
-          <a:p>
-            <a:pPr indent="0" marL="0">
-              <a:lnSpc>
-                <a:spcPct val="98000"/>
-              </a:lnSpc>
-              <a:buNone/>
-            </a:pPr>
-            <a:r>
-              <a:rPr lang="en-US" sz="3400" b="1" dirty="0">
-                <a:solidFill>
-                  <a:srgbClr val="F5294B"/>
-                </a:solidFill>
-                <a:latin typeface="Arial Narrow" pitchFamily="34" charset="0"/>
-                <a:ea typeface="Arial Narrow" pitchFamily="34" charset="-122"/>
-                <a:cs typeface="Arial Narrow" pitchFamily="34" charset="-120"/>
-              </a:rPr>
-              <a:t>00%</a:t>
-            </a:r>
-            <a:endParaRPr lang="en-US" sz="3400" dirty="0"/>
-          </a:p>
-          <a:p>
-            <a:pPr indent="0" marL="0">
-              <a:lnSpc>
-                <a:spcPct val="98000"/>
-              </a:lnSpc>
-              <a:spcBef>
-                <a:spcPts val="600"/>
-              </a:spcBef>
-              <a:buNone/>
-            </a:pPr>
-            <a:r>
-              <a:rPr lang="en-US" sz="1250" b="1" dirty="0">
-                <a:solidFill>
-                  <a:srgbClr val="F9F3F5"/>
-                </a:solidFill>
-                <a:latin typeface="Arial" pitchFamily="34" charset="0"/>
-                <a:ea typeface="Arial" pitchFamily="34" charset="-122"/>
-                <a:cs typeface="Arial" pitchFamily="34" charset="-120"/>
-              </a:rPr>
-              <a:t>Watch-through</a:t>
-            </a:r>
-            <a:endParaRPr lang="en-US" sz="3400" dirty="0"/>
-          </a:p>
-          <a:p>
-            <a:pPr indent="0" marL="0">
-              <a:lnSpc>
-                <a:spcPct val="98000"/>
-              </a:lnSpc>
-              <a:spcBef>
-                <a:spcPts val="300"/>
-              </a:spcBef>
-              <a:buNone/>
-            </a:pPr>
-            <a:r>
-              <a:rPr lang="en-US" sz="950" dirty="0">
-                <a:solidFill>
-                  <a:srgbClr val="A57E8B"/>
-                </a:solidFill>
-                <a:latin typeface="Arial" pitchFamily="34" charset="0"/>
-                <a:ea typeface="Arial" pitchFamily="34" charset="-122"/>
-                <a:cs typeface="Arial" pitchFamily="34" charset="-120"/>
-              </a:rPr>
-              <a:t>Avg completion on the video show</a:t>
-            </a:r>
-            <a:endParaRPr lang="en-US" sz="3400" dirty="0"/>
-          </a:p>
-        </p:txBody>
-      </p:sp>
-      <p:sp>
-        <p:nvSpPr>
-          <p:cNvPr id="11" name="Shape 9"/>
-          <p:cNvSpPr/>
-          <p:nvPr/>
-        </p:nvSpPr>
-        <p:spPr>
-          <a:xfrm>
-            <a:off x="6176772" y="2697480"/>
-            <a:ext cx="2695194" cy="1417320"/>
-          </a:xfrm>
-          <a:prstGeom prst="roundRect">
-            <a:avLst>
-              <a:gd name="adj" fmla="val 5806"/>
-            </a:avLst>
-          </a:prstGeom>
-          <a:solidFill>
-            <a:srgbClr val="1E0C13"/>
-          </a:solidFill>
-          <a:ln w="12700">
-            <a:solidFill>
-              <a:srgbClr val="43202C"/>
-            </a:solidFill>
-            <a:prstDash val="solid"/>
-          </a:ln>
-        </p:spPr>
-      </p:sp>
-      <p:sp>
-        <p:nvSpPr>
-          <p:cNvPr id="12" name="Text 10"/>
-          <p:cNvSpPr/>
-          <p:nvPr/>
-        </p:nvSpPr>
-        <p:spPr>
-          <a:xfrm>
-            <a:off x="6323076" y="2825496"/>
-            <a:ext cx="2402586" cy="1161288"/>
-          </a:xfrm>
-          <a:prstGeom prst="rect">
-            <a:avLst/>
-          </a:prstGeom>
-          <a:noFill/>
-          <a:ln/>
-        </p:spPr>
-        <p:txBody>
-          <a:bodyPr wrap="square" lIns="0" tIns="0" rIns="0" bIns="0" rtlCol="0" anchor="t"/>
-          <a:lstStyle/>
-          <a:p>
-            <a:pPr indent="0" marL="0">
-              <a:lnSpc>
-                <a:spcPct val="98000"/>
-              </a:lnSpc>
-              <a:buNone/>
-            </a:pPr>
-            <a:r>
-              <a:rPr lang="en-US" sz="3400" b="1" dirty="0">
-                <a:solidFill>
-                  <a:srgbClr val="F5294B"/>
-                </a:solidFill>
-                <a:latin typeface="Arial Narrow" pitchFamily="34" charset="0"/>
-                <a:ea typeface="Arial Narrow" pitchFamily="34" charset="-122"/>
-                <a:cs typeface="Arial Narrow" pitchFamily="34" charset="-120"/>
-              </a:rPr>
-              <a:t>00%</a:t>
-            </a:r>
-            <a:endParaRPr lang="en-US" sz="3400" dirty="0"/>
-          </a:p>
-          <a:p>
-            <a:pPr indent="0" marL="0">
-              <a:lnSpc>
-                <a:spcPct val="98000"/>
-              </a:lnSpc>
-              <a:spcBef>
-                <a:spcPts val="600"/>
-              </a:spcBef>
-              <a:buNone/>
-            </a:pPr>
-            <a:r>
-              <a:rPr lang="en-US" sz="1250" b="1" dirty="0">
-                <a:solidFill>
-                  <a:srgbClr val="F9F3F5"/>
-                </a:solidFill>
-                <a:latin typeface="Arial" pitchFamily="34" charset="0"/>
-                <a:ea typeface="Arial" pitchFamily="34" charset="-122"/>
-                <a:cs typeface="Arial" pitchFamily="34" charset="-120"/>
-              </a:rPr>
-              <a:t>Men 18–34</a:t>
-            </a:r>
-            <a:endParaRPr lang="en-US" sz="3400" dirty="0"/>
-          </a:p>
-          <a:p>
-            <a:pPr indent="0" marL="0">
-              <a:lnSpc>
-                <a:spcPct val="98000"/>
-              </a:lnSpc>
-              <a:spcBef>
-                <a:spcPts val="300"/>
-              </a:spcBef>
-              <a:buNone/>
-            </a:pPr>
-            <a:r>
-              <a:rPr lang="en-US" sz="950" dirty="0">
-                <a:solidFill>
-                  <a:srgbClr val="A57E8B"/>
-                </a:solidFill>
-                <a:latin typeface="Arial" pitchFamily="34" charset="0"/>
-                <a:ea typeface="Arial" pitchFamily="34" charset="-122"/>
-                <a:cs typeface="Arial" pitchFamily="34" charset="-120"/>
-              </a:rPr>
-              <a:t>The NFL's core AU growth demo</a:t>
-            </a:r>
-            <a:endParaRPr lang="en-US" sz="3400" dirty="0"/>
-          </a:p>
-        </p:txBody>
-      </p:sp>
-      <p:sp>
-        <p:nvSpPr>
-          <p:cNvPr id="13" name="Shape 11"/>
-          <p:cNvSpPr/>
-          <p:nvPr/>
-        </p:nvSpPr>
-        <p:spPr>
-          <a:xfrm>
-            <a:off x="9036558" y="2697480"/>
-            <a:ext cx="2695194" cy="1417320"/>
-          </a:xfrm>
-          <a:prstGeom prst="roundRect">
-            <a:avLst>
-              <a:gd name="adj" fmla="val 5806"/>
-            </a:avLst>
-          </a:prstGeom>
-          <a:solidFill>
-            <a:srgbClr val="1E0C13"/>
-          </a:solidFill>
-          <a:ln w="12700">
-            <a:solidFill>
-              <a:srgbClr val="43202C"/>
-            </a:solidFill>
-            <a:prstDash val="solid"/>
-          </a:ln>
-        </p:spPr>
-      </p:sp>
-      <p:sp>
-        <p:nvSpPr>
-          <p:cNvPr id="14" name="Text 12"/>
-          <p:cNvSpPr/>
-          <p:nvPr/>
-        </p:nvSpPr>
-        <p:spPr>
-          <a:xfrm>
-            <a:off x="9182862" y="2825496"/>
-            <a:ext cx="2402586" cy="1161288"/>
-          </a:xfrm>
-          <a:prstGeom prst="rect">
-            <a:avLst/>
-          </a:prstGeom>
-          <a:noFill/>
-          <a:ln/>
-        </p:spPr>
-        <p:txBody>
-          <a:bodyPr wrap="square" lIns="0" tIns="0" rIns="0" bIns="0" rtlCol="0" anchor="t"/>
-          <a:lstStyle/>
-          <a:p>
-            <a:pPr indent="0" marL="0">
-              <a:lnSpc>
-                <a:spcPct val="98000"/>
-              </a:lnSpc>
-              <a:buNone/>
-            </a:pPr>
-            <a:r>
-              <a:rPr lang="en-US" sz="3400" b="1" dirty="0">
-                <a:solidFill>
-                  <a:srgbClr val="F5294B"/>
-                </a:solidFill>
-                <a:latin typeface="Arial Narrow" pitchFamily="34" charset="0"/>
-                <a:ea typeface="Arial Narrow" pitchFamily="34" charset="-122"/>
-                <a:cs typeface="Arial Narrow" pitchFamily="34" charset="-120"/>
-              </a:rPr>
-              <a:t>000k</a:t>
-            </a:r>
-            <a:endParaRPr lang="en-US" sz="3400" dirty="0"/>
-          </a:p>
-          <a:p>
-            <a:pPr indent="0" marL="0">
-              <a:lnSpc>
-                <a:spcPct val="98000"/>
-              </a:lnSpc>
-              <a:spcBef>
-                <a:spcPts val="600"/>
-              </a:spcBef>
-              <a:buNone/>
-            </a:pPr>
-            <a:r>
-              <a:rPr lang="en-US" sz="1250" b="1" dirty="0">
-                <a:solidFill>
-                  <a:srgbClr val="F9F3F5"/>
-                </a:solidFill>
-                <a:latin typeface="Arial" pitchFamily="34" charset="0"/>
-                <a:ea typeface="Arial" pitchFamily="34" charset="-122"/>
-                <a:cs typeface="Arial" pitchFamily="34" charset="-120"/>
-              </a:rPr>
-              <a:t>Social reach / mo</a:t>
-            </a:r>
-            <a:endParaRPr lang="en-US" sz="3400" dirty="0"/>
-          </a:p>
-          <a:p>
-            <a:pPr indent="0" marL="0">
-              <a:lnSpc>
-                <a:spcPct val="98000"/>
-              </a:lnSpc>
-              <a:spcBef>
-                <a:spcPts val="300"/>
-              </a:spcBef>
-              <a:buNone/>
-            </a:pPr>
-            <a:r>
-              <a:rPr lang="en-US" sz="950" dirty="0">
-                <a:solidFill>
-                  <a:srgbClr val="A57E8B"/>
-                </a:solidFill>
-                <a:latin typeface="Arial" pitchFamily="34" charset="0"/>
-                <a:ea typeface="Arial" pitchFamily="34" charset="-122"/>
-                <a:cs typeface="Arial" pitchFamily="34" charset="-120"/>
-              </a:rPr>
-              <a:t>Instagram + TikTok combined</a:t>
-            </a:r>
-            <a:endParaRPr lang="en-US" sz="3400" dirty="0"/>
-          </a:p>
-        </p:txBody>
-      </p:sp>
-      <p:sp>
-        <p:nvSpPr>
-          <p:cNvPr id="15" name="Shape 13"/>
-          <p:cNvSpPr/>
-          <p:nvPr/>
-        </p:nvSpPr>
-        <p:spPr>
-          <a:xfrm>
-            <a:off x="457200" y="4315968"/>
-            <a:ext cx="6537960" cy="1938528"/>
-          </a:xfrm>
-          <a:prstGeom prst="roundRect">
-            <a:avLst>
-              <a:gd name="adj" fmla="val 4245"/>
-            </a:avLst>
-          </a:prstGeom>
-          <a:solidFill>
-            <a:srgbClr val="1E0C13"/>
-          </a:solidFill>
-          <a:ln w="12700">
-            <a:solidFill>
-              <a:srgbClr val="43202C"/>
-            </a:solidFill>
-            <a:prstDash val="solid"/>
-          </a:ln>
-        </p:spPr>
-      </p:sp>
-      <p:sp>
-        <p:nvSpPr>
-          <p:cNvPr id="16" name="Text 14"/>
-          <p:cNvSpPr/>
-          <p:nvPr/>
-        </p:nvSpPr>
-        <p:spPr>
-          <a:xfrm>
-            <a:off x="658368" y="4480560"/>
-            <a:ext cx="6135624" cy="274320"/>
-          </a:xfrm>
-          <a:prstGeom prst="rect">
-            <a:avLst/>
-          </a:prstGeom>
-          <a:noFill/>
-          <a:ln/>
-        </p:spPr>
-        <p:txBody>
-          <a:bodyPr wrap="square" lIns="0" tIns="0" rIns="0" bIns="0" rtlCol="0" anchor="ctr"/>
-          <a:lstStyle/>
-          <a:p>
-            <a:pPr indent="0" marL="0">
-              <a:buNone/>
-            </a:pPr>
-            <a:r>
-              <a:rPr lang="en-US" sz="1200" b="1" spc="200" kern="0" dirty="0">
-                <a:solidFill>
-                  <a:srgbClr val="DCC3CB"/>
-                </a:solidFill>
-                <a:latin typeface="Arial" pitchFamily="34" charset="0"/>
-                <a:ea typeface="Arial" pitchFamily="34" charset="-122"/>
-                <a:cs typeface="Arial" pitchFamily="34" charset="-120"/>
-              </a:rPr>
-              <a:t>WHO THEY ARE</a:t>
-            </a:r>
-            <a:endParaRPr lang="en-US" sz="1200" dirty="0"/>
-          </a:p>
-        </p:txBody>
-      </p:sp>
-      <p:sp>
-        <p:nvSpPr>
-          <p:cNvPr id="17" name="Text 15"/>
-          <p:cNvSpPr/>
-          <p:nvPr/>
-        </p:nvSpPr>
-        <p:spPr>
-          <a:xfrm>
-            <a:off x="658368" y="4828032"/>
-            <a:ext cx="6135624" cy="1280160"/>
-          </a:xfrm>
-          <a:prstGeom prst="rect">
-            <a:avLst/>
-          </a:prstGeom>
-          <a:noFill/>
-          <a:ln/>
-        </p:spPr>
-        <p:txBody>
-          <a:bodyPr wrap="square" lIns="0" tIns="0" rIns="0" bIns="0" rtlCol="0" anchor="t"/>
-          <a:lstStyle/>
-          <a:p>
-            <a:pPr marL="342900" indent="-342900">
-              <a:lnSpc>
-                <a:spcPct val="102000"/>
-              </a:lnSpc>
-              <a:spcAft>
-                <a:spcPts val="700"/>
-              </a:spcAft>
-              <a:buSzPct val="100000"/>
-              <a:buChar char="▸"/>
-            </a:pPr>
-            <a:r>
-              <a:rPr lang="en-US" sz="1250" dirty="0">
-                <a:solidFill>
-                  <a:srgbClr val="F9F3F5"/>
-                </a:solidFill>
-                <a:latin typeface="Arial" pitchFamily="34" charset="0"/>
-                <a:ea typeface="Arial" pitchFamily="34" charset="-122"/>
-                <a:cs typeface="Arial" pitchFamily="34" charset="-120"/>
-              </a:rPr>
-              <a:t>Already NFL-curious but under-served — no trusted Australian voice, no clear place to watch.</a:t>
-            </a:r>
-            <a:endParaRPr lang="en-US" sz="1250" dirty="0"/>
-          </a:p>
-          <a:p>
-            <a:pPr marL="342900" indent="-342900">
-              <a:lnSpc>
-                <a:spcPct val="102000"/>
-              </a:lnSpc>
-              <a:spcAft>
-                <a:spcPts val="700"/>
-              </a:spcAft>
-              <a:buSzPct val="100000"/>
-              <a:buChar char="▸"/>
-            </a:pPr>
-            <a:r>
-              <a:rPr lang="en-US" sz="1250" dirty="0">
-                <a:solidFill>
-                  <a:srgbClr val="F9F3F5"/>
-                </a:solidFill>
-                <a:latin typeface="Arial" pitchFamily="34" charset="0"/>
-                <a:ea typeface="Arial" pitchFamily="34" charset="-122"/>
-                <a:cs typeface="Arial" pitchFamily="34" charset="-120"/>
-              </a:rPr>
-              <a:t>Streaming-native: they subscribe readily and follow talent across platforms.</a:t>
-            </a:r>
-            <a:endParaRPr lang="en-US" sz="1250" dirty="0"/>
-          </a:p>
-          <a:p>
-            <a:pPr marL="342900" indent="-342900">
-              <a:lnSpc>
-                <a:spcPct val="102000"/>
-              </a:lnSpc>
-              <a:buSzPct val="100000"/>
-              <a:buChar char="▸"/>
-            </a:pPr>
-            <a:r>
-              <a:rPr lang="en-US" sz="1250" dirty="0">
-                <a:solidFill>
-                  <a:srgbClr val="F9F3F5"/>
-                </a:solidFill>
-                <a:latin typeface="Arial" pitchFamily="34" charset="0"/>
-                <a:ea typeface="Arial" pitchFamily="34" charset="-122"/>
-                <a:cs typeface="Arial" pitchFamily="34" charset="-120"/>
-              </a:rPr>
-              <a:t>Concentrated in the metro markets and the exact demo Disney+ and the NFL both want.</a:t>
-            </a:r>
-            <a:endParaRPr lang="en-US" sz="1250" dirty="0"/>
-          </a:p>
-        </p:txBody>
-      </p:sp>
-      <p:sp>
-        <p:nvSpPr>
-          <p:cNvPr id="18" name="Shape 16"/>
-          <p:cNvSpPr/>
-          <p:nvPr/>
-        </p:nvSpPr>
-        <p:spPr>
-          <a:xfrm>
-            <a:off x="7269480" y="4315968"/>
-            <a:ext cx="4462272" cy="1938528"/>
-          </a:xfrm>
-          <a:prstGeom prst="roundRect">
-            <a:avLst>
-              <a:gd name="adj" fmla="val 4245"/>
-            </a:avLst>
-          </a:prstGeom>
-          <a:solidFill>
-            <a:srgbClr val="2A111B"/>
-          </a:solidFill>
-          <a:ln w="12700">
-            <a:solidFill>
-              <a:srgbClr val="2E5B8C"/>
-            </a:solidFill>
-            <a:prstDash val="solid"/>
-          </a:ln>
-        </p:spPr>
-      </p:sp>
-      <p:sp>
-        <p:nvSpPr>
-          <p:cNvPr id="19" name="Text 17"/>
-          <p:cNvSpPr/>
-          <p:nvPr/>
-        </p:nvSpPr>
-        <p:spPr>
-          <a:xfrm>
-            <a:off x="7470648" y="4498848"/>
-            <a:ext cx="4059936" cy="274320"/>
-          </a:xfrm>
-          <a:prstGeom prst="rect">
-            <a:avLst/>
-          </a:prstGeom>
-          <a:noFill/>
-          <a:ln/>
-        </p:spPr>
-        <p:txBody>
-          <a:bodyPr wrap="square" lIns="0" tIns="0" rIns="0" bIns="0" rtlCol="0" anchor="ctr"/>
-          <a:lstStyle/>
-          <a:p>
-            <a:pPr indent="0" marL="0">
-              <a:buNone/>
-            </a:pPr>
-            <a:r>
-              <a:rPr lang="en-US" sz="1050" b="1" spc="150" kern="0" dirty="0">
-                <a:solidFill>
-                  <a:srgbClr val="5AA7FF"/>
-                </a:solidFill>
-                <a:latin typeface="Arial" pitchFamily="34" charset="0"/>
-                <a:ea typeface="Arial" pitchFamily="34" charset="-122"/>
-                <a:cs typeface="Arial" pitchFamily="34" charset="-120"/>
-              </a:rPr>
-              <a:t>WHY IT MATTERS TO DISNEY+</a:t>
-            </a:r>
-            <a:endParaRPr lang="en-US" sz="1050" dirty="0"/>
-          </a:p>
-        </p:txBody>
-      </p:sp>
-      <p:sp>
-        <p:nvSpPr>
-          <p:cNvPr id="20" name="Text 18"/>
-          <p:cNvSpPr/>
-          <p:nvPr/>
-        </p:nvSpPr>
-        <p:spPr>
-          <a:xfrm>
-            <a:off x="7470648" y="4919472"/>
-            <a:ext cx="4059936" cy="1115568"/>
-          </a:xfrm>
-          <a:prstGeom prst="rect">
-            <a:avLst/>
-          </a:prstGeom>
-          <a:noFill/>
-          <a:ln/>
-        </p:spPr>
-        <p:txBody>
-          <a:bodyPr wrap="square" lIns="0" tIns="0" rIns="0" bIns="0" rtlCol="0" anchor="t"/>
-          <a:lstStyle/>
-          <a:p>
-            <a:pPr indent="0" marL="0">
-              <a:lnSpc>
-                <a:spcPct val="108000"/>
-              </a:lnSpc>
-              <a:buNone/>
-            </a:pPr>
-            <a:r>
-              <a:rPr lang="en-US" sz="1500" dirty="0">
-                <a:solidFill>
-                  <a:srgbClr val="F9F3F5"/>
-                </a:solidFill>
-                <a:latin typeface="Arial" pitchFamily="34" charset="0"/>
-                <a:ea typeface="Arial" pitchFamily="34" charset="-122"/>
-                <a:cs typeface="Arial" pitchFamily="34" charset="-120"/>
-              </a:rPr>
-              <a:t>Every other slide is inventory. This is the </a:t>
-            </a:r>
-            <a:pPr indent="0" marL="0">
-              <a:lnSpc>
-                <a:spcPct val="108000"/>
-              </a:lnSpc>
-              <a:buNone/>
-            </a:pPr>
-            <a:r>
-              <a:rPr lang="en-US" sz="1500" b="1" dirty="0">
-                <a:solidFill>
-                  <a:srgbClr val="F5294B"/>
-                </a:solidFill>
-                <a:latin typeface="Arial" pitchFamily="34" charset="0"/>
-                <a:ea typeface="Arial" pitchFamily="34" charset="-122"/>
-                <a:cs typeface="Arial" pitchFamily="34" charset="-120"/>
-              </a:rPr>
-              <a:t>reason to buy it</a:t>
-            </a:r>
-            <a:pPr indent="0" marL="0">
-              <a:lnSpc>
-                <a:spcPct val="108000"/>
-              </a:lnSpc>
-              <a:buNone/>
-            </a:pPr>
-            <a:r>
-              <a:rPr lang="en-US" sz="1500" dirty="0">
-                <a:solidFill>
-                  <a:srgbClr val="F9F3F5"/>
-                </a:solidFill>
-                <a:latin typeface="Arial" pitchFamily="34" charset="0"/>
-                <a:ea typeface="Arial" pitchFamily="34" charset="-122"/>
-                <a:cs typeface="Arial" pitchFamily="34" charset="-120"/>
-              </a:rPr>
-              <a:t> — audited reach, engaged completion, and fit.</a:t>
-            </a:r>
-            <a:endParaRPr lang="en-US" sz="1500" dirty="0"/>
-          </a:p>
-        </p:txBody>
-      </p:sp>
-      <p:sp>
-        <p:nvSpPr>
-          <p:cNvPr id="21" name="Text 19"/>
-          <p:cNvSpPr/>
-          <p:nvPr/>
-        </p:nvSpPr>
-        <p:spPr>
-          <a:xfrm>
-            <a:off x="457200" y="6419088"/>
-            <a:ext cx="11274552" cy="320040"/>
-          </a:xfrm>
-          <a:prstGeom prst="rect">
-            <a:avLst/>
-          </a:prstGeom>
-          <a:noFill/>
-          <a:ln/>
-        </p:spPr>
-        <p:txBody>
-          <a:bodyPr wrap="square" lIns="0" tIns="0" rIns="0" bIns="0" rtlCol="0" anchor="t"/>
-          <a:lstStyle/>
-          <a:p>
-            <a:pPr indent="0" marL="0">
-              <a:buNone/>
-            </a:pPr>
-            <a:r>
-              <a:rPr lang="en-US" sz="950" dirty="0">
-                <a:solidFill>
-                  <a:srgbClr val="A57E8B"/>
-                </a:solidFill>
-                <a:latin typeface="Arial" pitchFamily="34" charset="0"/>
-                <a:ea typeface="Arial" pitchFamily="34" charset="-122"/>
-                <a:cs typeface="Arial" pitchFamily="34" charset="-120"/>
-              </a:rPr>
-              <a:t>Draft — replace bracketed figures with Armchair's actuals (downloads, watch-time, audience survey, socials). Live platform: armchair-nfl.vercel.app. Concept for pitch purposes; not affiliated with the NFL, ESPN or Disney+.</a:t>
-            </a:r>
-            <a:endParaRPr lang="en-US" sz="950" dirty="0"/>
-          </a:p>
-        </p:txBody>
-      </p:sp>
+      <p:pic>
+        <p:nvPicPr>
+          <p:cNvPr id="2" name="Image 0" descr="assets/flywheel.png">    </p:cNvPr>
+          <p:cNvPicPr>
+            <a:picLocks noChangeAspect="1"/>
+          </p:cNvPicPr>
+          <p:nvPr/>
+        </p:nvPicPr>
+        <p:blipFill>
+          <a:blip r:embed="rId1"/>
+          <a:stretch>
+            <a:fillRect/>
+          </a:stretch>
+        </p:blipFill>
+        <p:spPr>
+          <a:xfrm>
+            <a:off x="0" y="0"/>
+            <a:ext cx="12188952" cy="6858000"/>
+          </a:xfrm>
+          <a:prstGeom prst="rect">
+            <a:avLst/>
+          </a:prstGeom>
+        </p:spPr>
+      </p:pic>
     </p:spTree>
   </p:cSld>
   <p:clrMapOvr>
@@ -2279,7 +1351,7 @@
                 <a:ea typeface="Arial" pitchFamily="34" charset="-122"/>
                 <a:cs typeface="Arial" pitchFamily="34" charset="-120"/>
               </a:rPr>
-              <a:t>THE PROOF</a:t>
+              <a:t>THE AUDIENCE</a:t>
             </a:r>
             <a:endParaRPr lang="en-US" sz="1100" dirty="0"/>
           </a:p>
@@ -2321,7 +1393,7 @@
                 <a:ea typeface="Arial Narrow" pitchFamily="34" charset="-122"/>
                 <a:cs typeface="Arial Narrow" pitchFamily="34" charset="-120"/>
               </a:rPr>
-              <a:t>How we prove it drove subscriptions</a:t>
+              <a:t>Who Disney+ is really buying</a:t>
             </a:r>
             <a:endParaRPr lang="en-US" sz="4100" dirty="0"/>
           </a:p>
@@ -2363,7 +1435,7 @@
                 <a:ea typeface="Arial" pitchFamily="34" charset="-122"/>
                 <a:cs typeface="Arial" pitchFamily="34" charset="-120"/>
               </a:rPr>
-              <a:t>Turning “awareness” into a number Disney+ can bank — one tracked path from a mention to a sign-up.</a:t>
+              <a:t>Not impressions — a pre-qualified pool of streaming-ready NFL fans, indexed exactly where the league wants Australian growth.</a:t>
             </a:r>
             <a:endParaRPr lang="en-US" sz="1400" dirty="0"/>
           </a:p>
@@ -2378,11 +1450,11 @@
         <p:spPr>
           <a:xfrm>
             <a:off x="457200" y="2697480"/>
-            <a:ext cx="2695194" cy="1847088"/>
+            <a:ext cx="2695194" cy="1417320"/>
           </a:xfrm>
           <a:prstGeom prst="roundRect">
             <a:avLst>
-              <a:gd name="adj" fmla="val 4455"/>
+              <a:gd name="adj" fmla="val 5806"/>
             </a:avLst>
           </a:prstGeom>
           <a:solidFill>
@@ -2405,7 +1477,7 @@
         <p:spPr>
           <a:xfrm>
             <a:off x="603504" y="2825496"/>
-            <a:ext cx="2402586" cy="1170432"/>
+            <a:ext cx="2402586" cy="1161288"/>
           </a:xfrm>
           <a:prstGeom prst="rect">
             <a:avLst/>
@@ -2419,12 +1491,12 @@
           <a:p>
             <a:pPr indent="0" marL="0">
               <a:lnSpc>
-                <a:spcPct val="100000"/>
+                <a:spcPct val="98000"/>
               </a:lnSpc>
               <a:buNone/>
             </a:pPr>
             <a:r>
-              <a:rPr lang="en-US" sz="1600" b="1" spc="200" kern="0" dirty="0">
+              <a:rPr lang="en-US" sz="3400" b="1" dirty="0">
                 <a:solidFill>
                   <a:srgbClr val="F5294B"/>
                 </a:solidFill>
@@ -2432,14 +1504,37 @@
                 <a:ea typeface="Arial Narrow" pitchFamily="34" charset="-122"/>
                 <a:cs typeface="Arial Narrow" pitchFamily="34" charset="-120"/>
               </a:rPr>
-              <a:t>01</a:t>
-            </a:r>
-            <a:endParaRPr lang="en-US" sz="1600" dirty="0"/>
+              <a:t>000k</a:t>
+            </a:r>
+            <a:endParaRPr lang="en-US" sz="3400" dirty="0"/>
           </a:p>
           <a:p>
             <a:pPr indent="0" marL="0">
               <a:lnSpc>
-                <a:spcPct val="100000"/>
+                <a:spcPct val="98000"/>
+              </a:lnSpc>
+              <a:spcBef>
+                <a:spcPts val="600"/>
+              </a:spcBef>
+              <a:buNone/>
+            </a:pPr>
+            <a:r>
+              <a:rPr lang="en-US" sz="1250" b="1" dirty="0">
+                <a:solidFill>
+                  <a:srgbClr val="F9F3F5"/>
+                </a:solidFill>
+                <a:latin typeface="Arial" pitchFamily="34" charset="0"/>
+                <a:ea typeface="Arial" pitchFamily="34" charset="-122"/>
+                <a:cs typeface="Arial" pitchFamily="34" charset="-120"/>
+              </a:rPr>
+              <a:t>Monthly audience</a:t>
+            </a:r>
+            <a:endParaRPr lang="en-US" sz="3400" dirty="0"/>
+          </a:p>
+          <a:p>
+            <a:pPr indent="0" marL="0">
+              <a:lnSpc>
+                <a:spcPct val="98000"/>
               </a:lnSpc>
               <a:spcBef>
                 <a:spcPts val="300"/>
@@ -2447,155 +1542,34 @@
               <a:buNone/>
             </a:pPr>
             <a:r>
-              <a:rPr lang="en-US" sz="1600" b="1" spc="50" kern="0" dirty="0">
-                <a:solidFill>
-                  <a:srgbClr val="F9F3F5"/>
-                </a:solidFill>
-                <a:latin typeface="Arial Narrow" pitchFamily="34" charset="0"/>
-                <a:ea typeface="Arial Narrow" pitchFamily="34" charset="-122"/>
-                <a:cs typeface="Arial Narrow" pitchFamily="34" charset="-120"/>
-              </a:rPr>
-              <a:t>Awareness</a:t>
-            </a:r>
-            <a:endParaRPr lang="en-US" sz="1600" dirty="0"/>
-          </a:p>
-          <a:p>
-            <a:pPr indent="0" marL="0">
-              <a:lnSpc>
-                <a:spcPct val="100000"/>
-              </a:lnSpc>
-              <a:spcBef>
-                <a:spcPts val="600"/>
-              </a:spcBef>
-              <a:buNone/>
-            </a:pPr>
-            <a:r>
               <a:rPr lang="en-US" sz="950" dirty="0">
                 <a:solidFill>
-                  <a:srgbClr val="DCC3CB"/>
-                </a:solidFill>
-                <a:latin typeface="Arial" pitchFamily="34" charset="0"/>
-                <a:ea typeface="Arial" pitchFamily="34" charset="-122"/>
-                <a:cs typeface="Arial" pitchFamily="34" charset="-120"/>
-              </a:rPr>
-              <a:t>Show, social &amp; the iHeart network put the NFL story in front of fans.</a:t>
-            </a:r>
-            <a:endParaRPr lang="en-US" sz="1600" dirty="0"/>
-          </a:p>
-        </p:txBody>
-      </p:sp>
-      <p:sp>
-        <p:nvSpPr>
-          <p:cNvPr id="9" name="Text 7"/>
-          <p:cNvSpPr/>
-          <p:nvPr/>
-        </p:nvSpPr>
-        <p:spPr>
-          <a:xfrm>
-            <a:off x="603504" y="3977640"/>
-            <a:ext cx="2402586" cy="457200"/>
-          </a:xfrm>
-          <a:prstGeom prst="rect">
-            <a:avLst/>
-          </a:prstGeom>
-          <a:noFill/>
-          <a:ln/>
-        </p:spPr>
-        <p:txBody>
-          <a:bodyPr wrap="square" lIns="0" tIns="0" rIns="0" bIns="0" rtlCol="0" anchor="t"/>
-          <a:lstStyle/>
-          <a:p>
-            <a:pPr indent="0" marL="0">
-              <a:buNone/>
-            </a:pPr>
-            <a:r>
-              <a:rPr lang="en-US" sz="800" spc="150" kern="0" dirty="0">
-                <a:solidFill>
                   <a:srgbClr val="A57E8B"/>
                 </a:solidFill>
                 <a:latin typeface="Arial" pitchFamily="34" charset="0"/>
                 <a:ea typeface="Arial" pitchFamily="34" charset="-122"/>
                 <a:cs typeface="Arial" pitchFamily="34" charset="-120"/>
               </a:rPr>
-              <a:t>MEASURED BY</a:t>
-            </a:r>
-            <a:endParaRPr lang="en-US" sz="800" dirty="0"/>
-          </a:p>
-          <a:p>
-            <a:pPr indent="0" marL="0">
-              <a:spcBef>
-                <a:spcPts val="200"/>
-              </a:spcBef>
-              <a:buNone/>
-            </a:pPr>
-            <a:r>
-              <a:rPr lang="en-US" sz="1150" b="1" dirty="0">
-                <a:solidFill>
-                  <a:srgbClr val="43C58C"/>
-                </a:solidFill>
-                <a:latin typeface="Arial" pitchFamily="34" charset="0"/>
-                <a:ea typeface="Arial" pitchFamily="34" charset="-122"/>
-                <a:cs typeface="Arial" pitchFamily="34" charset="-120"/>
-              </a:rPr>
-              <a:t>Reach &amp; impressions</a:t>
-            </a:r>
-            <a:endParaRPr lang="en-US" sz="800" dirty="0"/>
-          </a:p>
-        </p:txBody>
-      </p:sp>
-      <p:sp>
-        <p:nvSpPr>
-          <p:cNvPr id="10" name="Text 8"/>
-          <p:cNvSpPr/>
-          <p:nvPr/>
-        </p:nvSpPr>
-        <p:spPr>
-          <a:xfrm>
-            <a:off x="3134106" y="3364992"/>
-            <a:ext cx="201168" cy="457200"/>
-          </a:xfrm>
-          <a:prstGeom prst="rect">
-            <a:avLst/>
-          </a:prstGeom>
-          <a:noFill/>
-          <a:ln/>
-        </p:spPr>
-        <p:txBody>
-          <a:bodyPr wrap="square" lIns="0" tIns="0" rIns="0" bIns="0" rtlCol="0" anchor="ctr"/>
-          <a:lstStyle/>
-          <a:p>
-            <a:pPr algn="ctr" indent="0" marL="0">
-              <a:buNone/>
-            </a:pPr>
-            <a:r>
-              <a:rPr lang="en-US" sz="2000" b="1" dirty="0">
-                <a:solidFill>
-                  <a:srgbClr val="A57E8B"/>
-                </a:solidFill>
-                <a:latin typeface="Arial" pitchFamily="34" charset="0"/>
-                <a:ea typeface="Arial" pitchFamily="34" charset="-122"/>
-                <a:cs typeface="Arial" pitchFamily="34" charset="-120"/>
-              </a:rPr>
-              <a:t>›</a:t>
-            </a:r>
-            <a:endParaRPr lang="en-US" sz="2000" dirty="0"/>
-          </a:p>
-        </p:txBody>
-      </p:sp>
-      <p:sp>
-        <p:nvSpPr>
-          <p:cNvPr id="11" name="Shape 9"/>
+              <a:t>Across audio, video &amp; social</a:t>
+            </a:r>
+            <a:endParaRPr lang="en-US" sz="3400" dirty="0"/>
+          </a:p>
+        </p:txBody>
+      </p:sp>
+      <p:sp>
+        <p:nvSpPr>
+          <p:cNvPr id="9" name="Shape 7"/>
           <p:cNvSpPr/>
           <p:nvPr/>
         </p:nvSpPr>
         <p:spPr>
           <a:xfrm>
             <a:off x="3316986" y="2697480"/>
-            <a:ext cx="2695194" cy="1847088"/>
+            <a:ext cx="2695194" cy="1417320"/>
           </a:xfrm>
           <a:prstGeom prst="roundRect">
             <a:avLst>
-              <a:gd name="adj" fmla="val 4455"/>
+              <a:gd name="adj" fmla="val 5806"/>
             </a:avLst>
           </a:prstGeom>
           <a:solidFill>
@@ -2611,14 +1585,14 @@
       </p:sp>
       <p:sp>
         <p:nvSpPr>
-          <p:cNvPr id="12" name="Text 10"/>
+          <p:cNvPr id="10" name="Text 8"/>
           <p:cNvSpPr/>
           <p:nvPr/>
         </p:nvSpPr>
         <p:spPr>
           <a:xfrm>
             <a:off x="3463290" y="2825496"/>
-            <a:ext cx="2402586" cy="1170432"/>
+            <a:ext cx="2402586" cy="1161288"/>
           </a:xfrm>
           <a:prstGeom prst="rect">
             <a:avLst/>
@@ -2632,12 +1606,12 @@
           <a:p>
             <a:pPr indent="0" marL="0">
               <a:lnSpc>
-                <a:spcPct val="100000"/>
+                <a:spcPct val="98000"/>
               </a:lnSpc>
               <a:buNone/>
             </a:pPr>
             <a:r>
-              <a:rPr lang="en-US" sz="1600" b="1" spc="200" kern="0" dirty="0">
+              <a:rPr lang="en-US" sz="3400" b="1" dirty="0">
                 <a:solidFill>
                   <a:srgbClr val="F5294B"/>
                 </a:solidFill>
@@ -2645,14 +1619,37 @@
                 <a:ea typeface="Arial Narrow" pitchFamily="34" charset="-122"/>
                 <a:cs typeface="Arial Narrow" pitchFamily="34" charset="-120"/>
               </a:rPr>
-              <a:t>02</a:t>
-            </a:r>
-            <a:endParaRPr lang="en-US" sz="1600" dirty="0"/>
+              <a:t>00%</a:t>
+            </a:r>
+            <a:endParaRPr lang="en-US" sz="3400" dirty="0"/>
           </a:p>
           <a:p>
             <a:pPr indent="0" marL="0">
               <a:lnSpc>
-                <a:spcPct val="100000"/>
+                <a:spcPct val="98000"/>
+              </a:lnSpc>
+              <a:spcBef>
+                <a:spcPts val="600"/>
+              </a:spcBef>
+              <a:buNone/>
+            </a:pPr>
+            <a:r>
+              <a:rPr lang="en-US" sz="1250" b="1" dirty="0">
+                <a:solidFill>
+                  <a:srgbClr val="F9F3F5"/>
+                </a:solidFill>
+                <a:latin typeface="Arial" pitchFamily="34" charset="0"/>
+                <a:ea typeface="Arial" pitchFamily="34" charset="-122"/>
+                <a:cs typeface="Arial" pitchFamily="34" charset="-120"/>
+              </a:rPr>
+              <a:t>Watch-through</a:t>
+            </a:r>
+            <a:endParaRPr lang="en-US" sz="3400" dirty="0"/>
+          </a:p>
+          <a:p>
+            <a:pPr indent="0" marL="0">
+              <a:lnSpc>
+                <a:spcPct val="98000"/>
               </a:lnSpc>
               <a:spcBef>
                 <a:spcPts val="300"/>
@@ -2660,155 +1657,34 @@
               <a:buNone/>
             </a:pPr>
             <a:r>
-              <a:rPr lang="en-US" sz="1600" b="1" spc="50" kern="0" dirty="0">
-                <a:solidFill>
-                  <a:srgbClr val="F9F3F5"/>
-                </a:solidFill>
-                <a:latin typeface="Arial Narrow" pitchFamily="34" charset="0"/>
-                <a:ea typeface="Arial Narrow" pitchFamily="34" charset="-122"/>
-                <a:cs typeface="Arial Narrow" pitchFamily="34" charset="-120"/>
-              </a:rPr>
-              <a:t>Intent</a:t>
-            </a:r>
-            <a:endParaRPr lang="en-US" sz="1600" dirty="0"/>
-          </a:p>
-          <a:p>
-            <a:pPr indent="0" marL="0">
-              <a:lnSpc>
-                <a:spcPct val="100000"/>
-              </a:lnSpc>
-              <a:spcBef>
-                <a:spcPts val="600"/>
-              </a:spcBef>
-              <a:buNone/>
-            </a:pPr>
-            <a:r>
               <a:rPr lang="en-US" sz="950" dirty="0">
                 <a:solidFill>
-                  <a:srgbClr val="DCC3CB"/>
-                </a:solidFill>
-                <a:latin typeface="Arial" pitchFamily="34" charset="0"/>
-                <a:ea typeface="Arial" pitchFamily="34" charset="-122"/>
-                <a:cs typeface="Arial" pitchFamily="34" charset="-120"/>
-              </a:rPr>
-              <a:t>A unique tracked deep-link &amp; on-air promo code in every episode.</a:t>
-            </a:r>
-            <a:endParaRPr lang="en-US" sz="1600" dirty="0"/>
-          </a:p>
-        </p:txBody>
-      </p:sp>
-      <p:sp>
-        <p:nvSpPr>
-          <p:cNvPr id="13" name="Text 11"/>
-          <p:cNvSpPr/>
-          <p:nvPr/>
-        </p:nvSpPr>
-        <p:spPr>
-          <a:xfrm>
-            <a:off x="3463290" y="3977640"/>
-            <a:ext cx="2402586" cy="457200"/>
-          </a:xfrm>
-          <a:prstGeom prst="rect">
-            <a:avLst/>
-          </a:prstGeom>
-          <a:noFill/>
-          <a:ln/>
-        </p:spPr>
-        <p:txBody>
-          <a:bodyPr wrap="square" lIns="0" tIns="0" rIns="0" bIns="0" rtlCol="0" anchor="t"/>
-          <a:lstStyle/>
-          <a:p>
-            <a:pPr indent="0" marL="0">
-              <a:buNone/>
-            </a:pPr>
-            <a:r>
-              <a:rPr lang="en-US" sz="800" spc="150" kern="0" dirty="0">
-                <a:solidFill>
                   <a:srgbClr val="A57E8B"/>
                 </a:solidFill>
                 <a:latin typeface="Arial" pitchFamily="34" charset="0"/>
                 <a:ea typeface="Arial" pitchFamily="34" charset="-122"/>
                 <a:cs typeface="Arial" pitchFamily="34" charset="-120"/>
               </a:rPr>
-              <a:t>MEASURED BY</a:t>
-            </a:r>
-            <a:endParaRPr lang="en-US" sz="800" dirty="0"/>
-          </a:p>
-          <a:p>
-            <a:pPr indent="0" marL="0">
-              <a:spcBef>
-                <a:spcPts val="200"/>
-              </a:spcBef>
-              <a:buNone/>
-            </a:pPr>
-            <a:r>
-              <a:rPr lang="en-US" sz="1150" b="1" dirty="0">
-                <a:solidFill>
-                  <a:srgbClr val="43C58C"/>
-                </a:solidFill>
-                <a:latin typeface="Arial" pitchFamily="34" charset="0"/>
-                <a:ea typeface="Arial" pitchFamily="34" charset="-122"/>
-                <a:cs typeface="Arial" pitchFamily="34" charset="-120"/>
-              </a:rPr>
-              <a:t>Click-through rate</a:t>
-            </a:r>
-            <a:endParaRPr lang="en-US" sz="800" dirty="0"/>
-          </a:p>
-        </p:txBody>
-      </p:sp>
-      <p:sp>
-        <p:nvSpPr>
-          <p:cNvPr id="14" name="Text 12"/>
-          <p:cNvSpPr/>
-          <p:nvPr/>
-        </p:nvSpPr>
-        <p:spPr>
-          <a:xfrm>
-            <a:off x="5993892" y="3364992"/>
-            <a:ext cx="201168" cy="457200"/>
-          </a:xfrm>
-          <a:prstGeom prst="rect">
-            <a:avLst/>
-          </a:prstGeom>
-          <a:noFill/>
-          <a:ln/>
-        </p:spPr>
-        <p:txBody>
-          <a:bodyPr wrap="square" lIns="0" tIns="0" rIns="0" bIns="0" rtlCol="0" anchor="ctr"/>
-          <a:lstStyle/>
-          <a:p>
-            <a:pPr algn="ctr" indent="0" marL="0">
-              <a:buNone/>
-            </a:pPr>
-            <a:r>
-              <a:rPr lang="en-US" sz="2000" b="1" dirty="0">
-                <a:solidFill>
-                  <a:srgbClr val="A57E8B"/>
-                </a:solidFill>
-                <a:latin typeface="Arial" pitchFamily="34" charset="0"/>
-                <a:ea typeface="Arial" pitchFamily="34" charset="-122"/>
-                <a:cs typeface="Arial" pitchFamily="34" charset="-120"/>
-              </a:rPr>
-              <a:t>›</a:t>
-            </a:r>
-            <a:endParaRPr lang="en-US" sz="2000" dirty="0"/>
-          </a:p>
-        </p:txBody>
-      </p:sp>
-      <p:sp>
-        <p:nvSpPr>
-          <p:cNvPr id="15" name="Shape 13"/>
+              <a:t>Avg completion on the video show</a:t>
+            </a:r>
+            <a:endParaRPr lang="en-US" sz="3400" dirty="0"/>
+          </a:p>
+        </p:txBody>
+      </p:sp>
+      <p:sp>
+        <p:nvSpPr>
+          <p:cNvPr id="11" name="Shape 9"/>
           <p:cNvSpPr/>
           <p:nvPr/>
         </p:nvSpPr>
         <p:spPr>
           <a:xfrm>
             <a:off x="6176772" y="2697480"/>
-            <a:ext cx="2695194" cy="1847088"/>
+            <a:ext cx="2695194" cy="1417320"/>
           </a:xfrm>
           <a:prstGeom prst="roundRect">
             <a:avLst>
-              <a:gd name="adj" fmla="val 4455"/>
+              <a:gd name="adj" fmla="val 5806"/>
             </a:avLst>
           </a:prstGeom>
           <a:solidFill>
@@ -2824,14 +1700,14 @@
       </p:sp>
       <p:sp>
         <p:nvSpPr>
-          <p:cNvPr id="16" name="Text 14"/>
+          <p:cNvPr id="12" name="Text 10"/>
           <p:cNvSpPr/>
           <p:nvPr/>
         </p:nvSpPr>
         <p:spPr>
           <a:xfrm>
             <a:off x="6323076" y="2825496"/>
-            <a:ext cx="2402586" cy="1170432"/>
+            <a:ext cx="2402586" cy="1161288"/>
           </a:xfrm>
           <a:prstGeom prst="rect">
             <a:avLst/>
@@ -2845,12 +1721,12 @@
           <a:p>
             <a:pPr indent="0" marL="0">
               <a:lnSpc>
-                <a:spcPct val="100000"/>
+                <a:spcPct val="98000"/>
               </a:lnSpc>
               <a:buNone/>
             </a:pPr>
             <a:r>
-              <a:rPr lang="en-US" sz="1600" b="1" spc="200" kern="0" dirty="0">
+              <a:rPr lang="en-US" sz="3400" b="1" dirty="0">
                 <a:solidFill>
                   <a:srgbClr val="F5294B"/>
                 </a:solidFill>
@@ -2858,14 +1734,37 @@
                 <a:ea typeface="Arial Narrow" pitchFamily="34" charset="-122"/>
                 <a:cs typeface="Arial Narrow" pitchFamily="34" charset="-120"/>
               </a:rPr>
-              <a:t>03</a:t>
-            </a:r>
-            <a:endParaRPr lang="en-US" sz="1600" dirty="0"/>
+              <a:t>00%</a:t>
+            </a:r>
+            <a:endParaRPr lang="en-US" sz="3400" dirty="0"/>
           </a:p>
           <a:p>
             <a:pPr indent="0" marL="0">
               <a:lnSpc>
-                <a:spcPct val="100000"/>
+                <a:spcPct val="98000"/>
+              </a:lnSpc>
+              <a:spcBef>
+                <a:spcPts val="600"/>
+              </a:spcBef>
+              <a:buNone/>
+            </a:pPr>
+            <a:r>
+              <a:rPr lang="en-US" sz="1250" b="1" dirty="0">
+                <a:solidFill>
+                  <a:srgbClr val="F9F3F5"/>
+                </a:solidFill>
+                <a:latin typeface="Arial" pitchFamily="34" charset="0"/>
+                <a:ea typeface="Arial" pitchFamily="34" charset="-122"/>
+                <a:cs typeface="Arial" pitchFamily="34" charset="-120"/>
+              </a:rPr>
+              <a:t>Men 18–34</a:t>
+            </a:r>
+            <a:endParaRPr lang="en-US" sz="3400" dirty="0"/>
+          </a:p>
+          <a:p>
+            <a:pPr indent="0" marL="0">
+              <a:lnSpc>
+                <a:spcPct val="98000"/>
               </a:lnSpc>
               <a:spcBef>
                 <a:spcPts val="300"/>
@@ -2873,155 +1772,34 @@
               <a:buNone/>
             </a:pPr>
             <a:r>
-              <a:rPr lang="en-US" sz="1600" b="1" spc="50" kern="0" dirty="0">
-                <a:solidFill>
-                  <a:srgbClr val="F9F3F5"/>
-                </a:solidFill>
-                <a:latin typeface="Arial Narrow" pitchFamily="34" charset="0"/>
-                <a:ea typeface="Arial Narrow" pitchFamily="34" charset="-122"/>
-                <a:cs typeface="Arial Narrow" pitchFamily="34" charset="-120"/>
-              </a:rPr>
-              <a:t>Conversion</a:t>
-            </a:r>
-            <a:endParaRPr lang="en-US" sz="1600" dirty="0"/>
-          </a:p>
-          <a:p>
-            <a:pPr indent="0" marL="0">
-              <a:lnSpc>
-                <a:spcPct val="100000"/>
-              </a:lnSpc>
-              <a:spcBef>
-                <a:spcPts val="600"/>
-              </a:spcBef>
-              <a:buNone/>
-            </a:pPr>
-            <a:r>
               <a:rPr lang="en-US" sz="950" dirty="0">
                 <a:solidFill>
-                  <a:srgbClr val="DCC3CB"/>
-                </a:solidFill>
-                <a:latin typeface="Arial" pitchFamily="34" charset="0"/>
-                <a:ea typeface="Arial" pitchFamily="34" charset="-122"/>
-                <a:cs typeface="Arial" pitchFamily="34" charset="-120"/>
-              </a:rPr>
-              <a:t>A co-branded, code-gated giveaway page captures the referral.</a:t>
-            </a:r>
-            <a:endParaRPr lang="en-US" sz="1600" dirty="0"/>
-          </a:p>
-        </p:txBody>
-      </p:sp>
-      <p:sp>
-        <p:nvSpPr>
-          <p:cNvPr id="17" name="Text 15"/>
-          <p:cNvSpPr/>
-          <p:nvPr/>
-        </p:nvSpPr>
-        <p:spPr>
-          <a:xfrm>
-            <a:off x="6323076" y="3977640"/>
-            <a:ext cx="2402586" cy="457200"/>
-          </a:xfrm>
-          <a:prstGeom prst="rect">
-            <a:avLst/>
-          </a:prstGeom>
-          <a:noFill/>
-          <a:ln/>
-        </p:spPr>
-        <p:txBody>
-          <a:bodyPr wrap="square" lIns="0" tIns="0" rIns="0" bIns="0" rtlCol="0" anchor="t"/>
-          <a:lstStyle/>
-          <a:p>
-            <a:pPr indent="0" marL="0">
-              <a:buNone/>
-            </a:pPr>
-            <a:r>
-              <a:rPr lang="en-US" sz="800" spc="150" kern="0" dirty="0">
-                <a:solidFill>
                   <a:srgbClr val="A57E8B"/>
                 </a:solidFill>
                 <a:latin typeface="Arial" pitchFamily="34" charset="0"/>
                 <a:ea typeface="Arial" pitchFamily="34" charset="-122"/>
                 <a:cs typeface="Arial" pitchFamily="34" charset="-120"/>
               </a:rPr>
-              <a:t>MEASURED BY</a:t>
-            </a:r>
-            <a:endParaRPr lang="en-US" sz="800" dirty="0"/>
-          </a:p>
-          <a:p>
-            <a:pPr indent="0" marL="0">
-              <a:spcBef>
-                <a:spcPts val="200"/>
-              </a:spcBef>
-              <a:buNone/>
-            </a:pPr>
-            <a:r>
-              <a:rPr lang="en-US" sz="1150" b="1" dirty="0">
-                <a:solidFill>
-                  <a:srgbClr val="43C58C"/>
-                </a:solidFill>
-                <a:latin typeface="Arial" pitchFamily="34" charset="0"/>
-                <a:ea typeface="Arial" pitchFamily="34" charset="-122"/>
-                <a:cs typeface="Arial" pitchFamily="34" charset="-120"/>
-              </a:rPr>
-              <a:t>Attributed sign-ups</a:t>
-            </a:r>
-            <a:endParaRPr lang="en-US" sz="800" dirty="0"/>
-          </a:p>
-        </p:txBody>
-      </p:sp>
-      <p:sp>
-        <p:nvSpPr>
-          <p:cNvPr id="18" name="Text 16"/>
-          <p:cNvSpPr/>
-          <p:nvPr/>
-        </p:nvSpPr>
-        <p:spPr>
-          <a:xfrm>
-            <a:off x="8853678" y="3364992"/>
-            <a:ext cx="201168" cy="457200"/>
-          </a:xfrm>
-          <a:prstGeom prst="rect">
-            <a:avLst/>
-          </a:prstGeom>
-          <a:noFill/>
-          <a:ln/>
-        </p:spPr>
-        <p:txBody>
-          <a:bodyPr wrap="square" lIns="0" tIns="0" rIns="0" bIns="0" rtlCol="0" anchor="ctr"/>
-          <a:lstStyle/>
-          <a:p>
-            <a:pPr algn="ctr" indent="0" marL="0">
-              <a:buNone/>
-            </a:pPr>
-            <a:r>
-              <a:rPr lang="en-US" sz="2000" b="1" dirty="0">
-                <a:solidFill>
-                  <a:srgbClr val="A57E8B"/>
-                </a:solidFill>
-                <a:latin typeface="Arial" pitchFamily="34" charset="0"/>
-                <a:ea typeface="Arial" pitchFamily="34" charset="-122"/>
-                <a:cs typeface="Arial" pitchFamily="34" charset="-120"/>
-              </a:rPr>
-              <a:t>›</a:t>
-            </a:r>
-            <a:endParaRPr lang="en-US" sz="2000" dirty="0"/>
-          </a:p>
-        </p:txBody>
-      </p:sp>
-      <p:sp>
-        <p:nvSpPr>
-          <p:cNvPr id="19" name="Shape 17"/>
+              <a:t>The NFL's core AU growth demo</a:t>
+            </a:r>
+            <a:endParaRPr lang="en-US" sz="3400" dirty="0"/>
+          </a:p>
+        </p:txBody>
+      </p:sp>
+      <p:sp>
+        <p:nvSpPr>
+          <p:cNvPr id="13" name="Shape 11"/>
           <p:cNvSpPr/>
           <p:nvPr/>
         </p:nvSpPr>
         <p:spPr>
           <a:xfrm>
             <a:off x="9036558" y="2697480"/>
-            <a:ext cx="2695194" cy="1847088"/>
+            <a:ext cx="2695194" cy="1417320"/>
           </a:xfrm>
           <a:prstGeom prst="roundRect">
             <a:avLst>
-              <a:gd name="adj" fmla="val 4455"/>
+              <a:gd name="adj" fmla="val 5806"/>
             </a:avLst>
           </a:prstGeom>
           <a:solidFill>
@@ -3037,14 +1815,14 @@
       </p:sp>
       <p:sp>
         <p:nvSpPr>
-          <p:cNvPr id="20" name="Text 18"/>
+          <p:cNvPr id="14" name="Text 12"/>
           <p:cNvSpPr/>
           <p:nvPr/>
         </p:nvSpPr>
         <p:spPr>
           <a:xfrm>
             <a:off x="9182862" y="2825496"/>
-            <a:ext cx="2402586" cy="1170432"/>
+            <a:ext cx="2402586" cy="1161288"/>
           </a:xfrm>
           <a:prstGeom prst="rect">
             <a:avLst/>
@@ -3058,12 +1836,12 @@
           <a:p>
             <a:pPr indent="0" marL="0">
               <a:lnSpc>
-                <a:spcPct val="100000"/>
+                <a:spcPct val="98000"/>
               </a:lnSpc>
               <a:buNone/>
             </a:pPr>
             <a:r>
-              <a:rPr lang="en-US" sz="1600" b="1" spc="200" kern="0" dirty="0">
+              <a:rPr lang="en-US" sz="3400" b="1" dirty="0">
                 <a:solidFill>
                   <a:srgbClr val="F5294B"/>
                 </a:solidFill>
@@ -3071,14 +1849,37 @@
                 <a:ea typeface="Arial Narrow" pitchFamily="34" charset="-122"/>
                 <a:cs typeface="Arial Narrow" pitchFamily="34" charset="-120"/>
               </a:rPr>
-              <a:t>04</a:t>
-            </a:r>
-            <a:endParaRPr lang="en-US" sz="1600" dirty="0"/>
+              <a:t>000k</a:t>
+            </a:r>
+            <a:endParaRPr lang="en-US" sz="3400" dirty="0"/>
           </a:p>
           <a:p>
             <a:pPr indent="0" marL="0">
               <a:lnSpc>
-                <a:spcPct val="100000"/>
+                <a:spcPct val="98000"/>
+              </a:lnSpc>
+              <a:spcBef>
+                <a:spcPts val="600"/>
+              </a:spcBef>
+              <a:buNone/>
+            </a:pPr>
+            <a:r>
+              <a:rPr lang="en-US" sz="1250" b="1" dirty="0">
+                <a:solidFill>
+                  <a:srgbClr val="F9F3F5"/>
+                </a:solidFill>
+                <a:latin typeface="Arial" pitchFamily="34" charset="0"/>
+                <a:ea typeface="Arial" pitchFamily="34" charset="-122"/>
+                <a:cs typeface="Arial" pitchFamily="34" charset="-120"/>
+              </a:rPr>
+              <a:t>Social reach / mo</a:t>
+            </a:r>
+            <a:endParaRPr lang="en-US" sz="3400" dirty="0"/>
+          </a:p>
+          <a:p>
+            <a:pPr indent="0" marL="0">
+              <a:lnSpc>
+                <a:spcPct val="98000"/>
               </a:lnSpc>
               <a:spcBef>
                 <a:spcPts val="300"/>
@@ -3086,116 +1887,34 @@
               <a:buNone/>
             </a:pPr>
             <a:r>
-              <a:rPr lang="en-US" sz="1600" b="1" spc="50" kern="0" dirty="0">
-                <a:solidFill>
-                  <a:srgbClr val="F9F3F5"/>
-                </a:solidFill>
-                <a:latin typeface="Arial Narrow" pitchFamily="34" charset="0"/>
-                <a:ea typeface="Arial Narrow" pitchFamily="34" charset="-122"/>
-                <a:cs typeface="Arial Narrow" pitchFamily="34" charset="-120"/>
-              </a:rPr>
-              <a:t>Prove it</a:t>
-            </a:r>
-            <a:endParaRPr lang="en-US" sz="1600" dirty="0"/>
-          </a:p>
-          <a:p>
-            <a:pPr indent="0" marL="0">
-              <a:lnSpc>
-                <a:spcPct val="100000"/>
-              </a:lnSpc>
-              <a:spcBef>
-                <a:spcPts val="600"/>
-              </a:spcBef>
-              <a:buNone/>
-            </a:pPr>
-            <a:r>
               <a:rPr lang="en-US" sz="950" dirty="0">
                 <a:solidFill>
-                  <a:srgbClr val="DCC3CB"/>
-                </a:solidFill>
-                <a:latin typeface="Arial" pitchFamily="34" charset="0"/>
-                <a:ea typeface="Arial" pitchFamily="34" charset="-122"/>
-                <a:cs typeface="Arial" pitchFamily="34" charset="-120"/>
-              </a:rPr>
-              <a:t>A shared dashboard reconciles spend against sign-ups fortnightly.</a:t>
-            </a:r>
-            <a:endParaRPr lang="en-US" sz="1600" dirty="0"/>
-          </a:p>
-        </p:txBody>
-      </p:sp>
-      <p:sp>
-        <p:nvSpPr>
-          <p:cNvPr id="21" name="Text 19"/>
-          <p:cNvSpPr/>
-          <p:nvPr/>
-        </p:nvSpPr>
-        <p:spPr>
-          <a:xfrm>
-            <a:off x="9182862" y="3977640"/>
-            <a:ext cx="2402586" cy="457200"/>
-          </a:xfrm>
-          <a:prstGeom prst="rect">
-            <a:avLst/>
-          </a:prstGeom>
-          <a:noFill/>
-          <a:ln/>
-        </p:spPr>
-        <p:txBody>
-          <a:bodyPr wrap="square" lIns="0" tIns="0" rIns="0" bIns="0" rtlCol="0" anchor="t"/>
-          <a:lstStyle/>
-          <a:p>
-            <a:pPr indent="0" marL="0">
-              <a:buNone/>
-            </a:pPr>
-            <a:r>
-              <a:rPr lang="en-US" sz="800" spc="150" kern="0" dirty="0">
-                <a:solidFill>
                   <a:srgbClr val="A57E8B"/>
                 </a:solidFill>
                 <a:latin typeface="Arial" pitchFamily="34" charset="0"/>
                 <a:ea typeface="Arial" pitchFamily="34" charset="-122"/>
                 <a:cs typeface="Arial" pitchFamily="34" charset="-120"/>
               </a:rPr>
-              <a:t>MEASURED BY</a:t>
-            </a:r>
-            <a:endParaRPr lang="en-US" sz="800" dirty="0"/>
-          </a:p>
-          <a:p>
-            <a:pPr indent="0" marL="0">
-              <a:spcBef>
-                <a:spcPts val="200"/>
-              </a:spcBef>
-              <a:buNone/>
-            </a:pPr>
-            <a:r>
-              <a:rPr lang="en-US" sz="1150" b="1" dirty="0">
-                <a:solidFill>
-                  <a:srgbClr val="43C58C"/>
-                </a:solidFill>
-                <a:latin typeface="Arial" pitchFamily="34" charset="0"/>
-                <a:ea typeface="Arial" pitchFamily="34" charset="-122"/>
-                <a:cs typeface="Arial" pitchFamily="34" charset="-120"/>
-              </a:rPr>
-              <a:t>Cost per acquisition</a:t>
-            </a:r>
-            <a:endParaRPr lang="en-US" sz="800" dirty="0"/>
-          </a:p>
-        </p:txBody>
-      </p:sp>
-      <p:sp>
-        <p:nvSpPr>
-          <p:cNvPr id="22" name="Shape 20"/>
-          <p:cNvSpPr/>
-          <p:nvPr/>
-        </p:nvSpPr>
-        <p:spPr>
-          <a:xfrm>
-            <a:off x="457200" y="4681728"/>
-            <a:ext cx="6537960" cy="1572768"/>
+              <a:t>Instagram + TikTok combined</a:t>
+            </a:r>
+            <a:endParaRPr lang="en-US" sz="3400" dirty="0"/>
+          </a:p>
+        </p:txBody>
+      </p:sp>
+      <p:sp>
+        <p:nvSpPr>
+          <p:cNvPr id="15" name="Shape 13"/>
+          <p:cNvSpPr/>
+          <p:nvPr/>
+        </p:nvSpPr>
+        <p:spPr>
+          <a:xfrm>
+            <a:off x="457200" y="4315968"/>
+            <a:ext cx="6537960" cy="1938528"/>
           </a:xfrm>
           <a:prstGeom prst="roundRect">
             <a:avLst>
-              <a:gd name="adj" fmla="val 5233"/>
+              <a:gd name="adj" fmla="val 4245"/>
             </a:avLst>
           </a:prstGeom>
           <a:solidFill>
@@ -3211,13 +1930,13 @@
       </p:sp>
       <p:sp>
         <p:nvSpPr>
-          <p:cNvPr id="23" name="Text 21"/>
-          <p:cNvSpPr/>
-          <p:nvPr/>
-        </p:nvSpPr>
-        <p:spPr>
-          <a:xfrm>
-            <a:off x="658368" y="4828032"/>
+          <p:cNvPr id="16" name="Text 14"/>
+          <p:cNvSpPr/>
+          <p:nvPr/>
+        </p:nvSpPr>
+        <p:spPr>
+          <a:xfrm>
+            <a:off x="658368" y="4480560"/>
             <a:ext cx="6135624" cy="274320"/>
           </a:xfrm>
           <a:prstGeom prst="rect">
@@ -3242,7 +1961,7 @@
                 <a:ea typeface="Arial" pitchFamily="34" charset="-122"/>
                 <a:cs typeface="Arial" pitchFamily="34" charset="-120"/>
               </a:rPr>
-              <a:t>HOW IT'S WIRED</a:t>
+              <a:t>WHO THEY ARE</a:t>
             </a:r>
             <a:endParaRPr lang="en-US" sz="1200" dirty="0"/>
           </a:p>
@@ -3250,14 +1969,14 @@
       </p:sp>
       <p:sp>
         <p:nvSpPr>
-          <p:cNvPr id="24" name="Text 22"/>
-          <p:cNvSpPr/>
-          <p:nvPr/>
-        </p:nvSpPr>
-        <p:spPr>
-          <a:xfrm>
-            <a:off x="658368" y="5157216"/>
-            <a:ext cx="6135624" cy="969264"/>
+          <p:cNvPr id="17" name="Text 15"/>
+          <p:cNvSpPr/>
+          <p:nvPr/>
+        </p:nvSpPr>
+        <p:spPr>
+          <a:xfrm>
+            <a:off x="658368" y="4828032"/>
+            <a:ext cx="6135624" cy="1280160"/>
           </a:xfrm>
           <a:prstGeom prst="rect">
             <a:avLst/>
@@ -3274,14 +1993,13 @@
                 <a:spcPct val="102000"/>
               </a:lnSpc>
               <a:spcAft>
-                <a:spcPts val="600"/>
+                <a:spcPts val="700"/>
               </a:spcAft>
               <a:buSzPct val="100000"/>
-              <a:buFont typeface="+mj-lt"/>
-              <a:buAutoNum type="arabicPeriod" startAt="1"/>
-            </a:pPr>
-            <a:r>
-              <a:rPr lang="en-US" sz="1200" dirty="0">
+              <a:buChar char="▸"/>
+            </a:pPr>
+            <a:r>
+              <a:rPr lang="en-US" sz="1250" dirty="0">
                 <a:solidFill>
                   <a:srgbClr val="F9F3F5"/>
                 </a:solidFill>
@@ -3289,9 +2007,9 @@
                 <a:ea typeface="Arial" pitchFamily="34" charset="-122"/>
                 <a:cs typeface="Arial" pitchFamily="34" charset="-120"/>
               </a:rPr>
-              <a:t>A unique UTM deep-link &amp; Disney+ promo code per episode — credit is unambiguous.</a:t>
-            </a:r>
-            <a:endParaRPr lang="en-US" sz="1200" dirty="0"/>
+              <a:t>Already NFL-curious but under-served — no trusted Australian voice, no clear place to watch.</a:t>
+            </a:r>
+            <a:endParaRPr lang="en-US" sz="1250" dirty="0"/>
           </a:p>
           <a:p>
             <a:pPr marL="342900" indent="-342900">
@@ -3299,14 +2017,13 @@
                 <a:spcPct val="102000"/>
               </a:lnSpc>
               <a:spcAft>
-                <a:spcPts val="600"/>
+                <a:spcPts val="700"/>
               </a:spcAft>
               <a:buSzPct val="100000"/>
-              <a:buFont typeface="+mj-lt"/>
-              <a:buAutoNum type="arabicPeriod" startAt="1"/>
-            </a:pPr>
-            <a:r>
-              <a:rPr lang="en-US" sz="1200" dirty="0">
+              <a:buChar char="▸"/>
+            </a:pPr>
+            <a:r>
+              <a:rPr lang="en-US" sz="1250" dirty="0">
                 <a:solidFill>
                   <a:srgbClr val="F9F3F5"/>
                 </a:solidFill>
@@ -3314,9 +2031,9 @@
                 <a:ea typeface="Arial" pitchFamily="34" charset="-122"/>
                 <a:cs typeface="Arial" pitchFamily="34" charset="-120"/>
               </a:rPr>
-              <a:t>A giveaway landing page that gates entry behind the sign-up path.</a:t>
-            </a:r>
-            <a:endParaRPr lang="en-US" sz="1200" dirty="0"/>
+              <a:t>Streaming-native: they subscribe readily and follow talent across platforms.</a:t>
+            </a:r>
+            <a:endParaRPr lang="en-US" sz="1250" dirty="0"/>
           </a:p>
           <a:p>
             <a:pPr marL="342900" indent="-342900">
@@ -3324,11 +2041,10 @@
                 <a:spcPct val="102000"/>
               </a:lnSpc>
               <a:buSzPct val="100000"/>
-              <a:buFont typeface="+mj-lt"/>
-              <a:buAutoNum type="arabicPeriod" startAt="1"/>
-            </a:pPr>
-            <a:r>
-              <a:rPr lang="en-US" sz="1200" dirty="0">
+              <a:buChar char="▸"/>
+            </a:pPr>
+            <a:r>
+              <a:rPr lang="en-US" sz="1250" dirty="0">
                 <a:solidFill>
                   <a:srgbClr val="F9F3F5"/>
                 </a:solidFill>
@@ -3336,26 +2052,26 @@
                 <a:ea typeface="Arial" pitchFamily="34" charset="-122"/>
                 <a:cs typeface="Arial" pitchFamily="34" charset="-120"/>
               </a:rPr>
-              <a:t>A fortnightly report to Disney+ — reach, clicks, sign-ups, CPA. Nothing behind the curtain.</a:t>
-            </a:r>
-            <a:endParaRPr lang="en-US" sz="1200" dirty="0"/>
-          </a:p>
-        </p:txBody>
-      </p:sp>
-      <p:sp>
-        <p:nvSpPr>
-          <p:cNvPr id="25" name="Shape 23"/>
-          <p:cNvSpPr/>
-          <p:nvPr/>
-        </p:nvSpPr>
-        <p:spPr>
-          <a:xfrm>
-            <a:off x="7269480" y="4681728"/>
-            <a:ext cx="4462272" cy="1572768"/>
+              <a:t>Concentrated in the metro markets and the exact demo Disney+ and the NFL both want.</a:t>
+            </a:r>
+            <a:endParaRPr lang="en-US" sz="1250" dirty="0"/>
+          </a:p>
+        </p:txBody>
+      </p:sp>
+      <p:sp>
+        <p:nvSpPr>
+          <p:cNvPr id="18" name="Shape 16"/>
+          <p:cNvSpPr/>
+          <p:nvPr/>
+        </p:nvSpPr>
+        <p:spPr>
+          <a:xfrm>
+            <a:off x="7269480" y="4315968"/>
+            <a:ext cx="4462272" cy="1938528"/>
           </a:xfrm>
           <a:prstGeom prst="roundRect">
             <a:avLst>
-              <a:gd name="adj" fmla="val 5233"/>
+              <a:gd name="adj" fmla="val 4245"/>
             </a:avLst>
           </a:prstGeom>
           <a:solidFill>
@@ -3371,13 +2087,13 @@
       </p:sp>
       <p:sp>
         <p:nvSpPr>
-          <p:cNvPr id="26" name="Text 24"/>
-          <p:cNvSpPr/>
-          <p:nvPr/>
-        </p:nvSpPr>
-        <p:spPr>
-          <a:xfrm>
-            <a:off x="7470648" y="4846320"/>
+          <p:cNvPr id="19" name="Text 17"/>
+          <p:cNvSpPr/>
+          <p:nvPr/>
+        </p:nvSpPr>
+        <p:spPr>
+          <a:xfrm>
+            <a:off x="7470648" y="4498848"/>
             <a:ext cx="4059936" cy="274320"/>
           </a:xfrm>
           <a:prstGeom prst="rect">
@@ -3402,7 +2118,7 @@
                 <a:ea typeface="Arial" pitchFamily="34" charset="-122"/>
                 <a:cs typeface="Arial" pitchFamily="34" charset="-120"/>
               </a:rPr>
-              <a:t>THE UNLOCK — ALREADY LIVE</a:t>
+              <a:t>WHY IT MATTERS TO DISNEY+</a:t>
             </a:r>
             <a:endParaRPr lang="en-US" sz="1050" dirty="0"/>
           </a:p>
@@ -3410,14 +2126,14 @@
       </p:sp>
       <p:sp>
         <p:nvSpPr>
-          <p:cNvPr id="27" name="Text 25"/>
-          <p:cNvSpPr/>
-          <p:nvPr/>
-        </p:nvSpPr>
-        <p:spPr>
-          <a:xfrm>
-            <a:off x="7470648" y="5212080"/>
-            <a:ext cx="4059936" cy="914400"/>
+          <p:cNvPr id="20" name="Text 18"/>
+          <p:cNvSpPr/>
+          <p:nvPr/>
+        </p:nvSpPr>
+        <p:spPr>
+          <a:xfrm>
+            <a:off x="7470648" y="4919472"/>
+            <a:ext cx="4059936" cy="1115568"/>
           </a:xfrm>
           <a:prstGeom prst="rect">
             <a:avLst/>
@@ -3431,12 +2147,12 @@
           <a:p>
             <a:pPr indent="0" marL="0">
               <a:lnSpc>
-                <a:spcPct val="106000"/>
+                <a:spcPct val="108000"/>
               </a:lnSpc>
               <a:buNone/>
             </a:pPr>
             <a:r>
-              <a:rPr lang="en-US" sz="1300" dirty="0">
+              <a:rPr lang="en-US" sz="1500" dirty="0">
                 <a:solidFill>
                   <a:srgbClr val="F9F3F5"/>
                 </a:solidFill>
@@ -3444,16 +2160,16 @@
                 <a:ea typeface="Arial" pitchFamily="34" charset="-122"/>
                 <a:cs typeface="Arial" pitchFamily="34" charset="-120"/>
               </a:rPr>
-              <a:t>Every </a:t>
+              <a:t>Every other slide is inventory. This is the </a:t>
             </a:r>
             <a:pPr indent="0" marL="0">
               <a:lnSpc>
-                <a:spcPct val="106000"/>
+                <a:spcPct val="108000"/>
               </a:lnSpc>
               <a:buNone/>
             </a:pPr>
             <a:r>
-              <a:rPr lang="en-US" sz="1300" b="1" dirty="0">
+              <a:rPr lang="en-US" sz="1500" b="1" dirty="0">
                 <a:solidFill>
                   <a:srgbClr val="F5294B"/>
                 </a:solidFill>
@@ -3461,16 +2177,16 @@
                 <a:ea typeface="Arial" pitchFamily="34" charset="-122"/>
                 <a:cs typeface="Arial" pitchFamily="34" charset="-120"/>
               </a:rPr>
-              <a:t>“Watch on Disney+”</a:t>
+              <a:t>reason to buy it</a:t>
             </a:r>
             <a:pPr indent="0" marL="0">
               <a:lnSpc>
-                <a:spcPct val="106000"/>
+                <a:spcPct val="108000"/>
               </a:lnSpc>
               <a:buNone/>
             </a:pPr>
             <a:r>
-              <a:rPr lang="en-US" sz="1300" dirty="0">
+              <a:rPr lang="en-US" sz="1500" dirty="0">
                 <a:solidFill>
                   <a:srgbClr val="F9F3F5"/>
                 </a:solidFill>
@@ -3478,49 +2194,15 @@
                 <a:ea typeface="Arial" pitchFamily="34" charset="-122"/>
                 <a:cs typeface="Arial" pitchFamily="34" charset="-120"/>
               </a:rPr>
-              <a:t> tap in the hub is one of these tracked links — and the hub is running today at </a:t>
-            </a:r>
-            <a:pPr indent="0" marL="0">
-              <a:lnSpc>
-                <a:spcPct val="106000"/>
-              </a:lnSpc>
-              <a:buNone/>
-            </a:pPr>
-            <a:r>
-              <a:rPr lang="en-US" sz="1300" b="1" dirty="0">
-                <a:solidFill>
-                  <a:srgbClr val="5AA7FF"/>
-                </a:solidFill>
-                <a:latin typeface="Arial" pitchFamily="34" charset="0"/>
-                <a:ea typeface="Arial" pitchFamily="34" charset="-122"/>
-                <a:cs typeface="Arial" pitchFamily="34" charset="-120"/>
-              </a:rPr>
-              <a:t>armchair-nfl.vercel.app</a:t>
-            </a:r>
-            <a:pPr indent="0" marL="0">
-              <a:lnSpc>
-                <a:spcPct val="106000"/>
-              </a:lnSpc>
-              <a:buNone/>
-            </a:pPr>
-            <a:r>
-              <a:rPr lang="en-US" sz="1300" dirty="0">
-                <a:solidFill>
-                  <a:srgbClr val="F9F3F5"/>
-                </a:solidFill>
-                <a:latin typeface="Arial" pitchFamily="34" charset="0"/>
-                <a:ea typeface="Arial" pitchFamily="34" charset="-122"/>
-                <a:cs typeface="Arial" pitchFamily="34" charset="-120"/>
-              </a:rPr>
-              <a:t>. Product and measurement are the same system.</a:t>
-            </a:r>
-            <a:endParaRPr lang="en-US" sz="1300" dirty="0"/>
-          </a:p>
-        </p:txBody>
-      </p:sp>
-      <p:sp>
-        <p:nvSpPr>
-          <p:cNvPr id="28" name="Text 26"/>
+              <a:t> — audited reach, engaged completion, and fit.</a:t>
+            </a:r>
+            <a:endParaRPr lang="en-US" sz="1500" dirty="0"/>
+          </a:p>
+        </p:txBody>
+      </p:sp>
+      <p:sp>
+        <p:nvSpPr>
+          <p:cNvPr id="21" name="Text 19"/>
           <p:cNvSpPr/>
           <p:nvPr/>
         </p:nvSpPr>
@@ -3551,7 +2233,7 @@
                 <a:ea typeface="Arial" pitchFamily="34" charset="-122"/>
                 <a:cs typeface="Arial" pitchFamily="34" charset="-120"/>
               </a:rPr>
-              <a:t>Live platform: armchair-nfl.vercel.app — palette &amp; type match, so the pitch reads as one system. Concept for pitch purposes; not affiliated with the NFL, ESPN or Disney+.</a:t>
+              <a:t>Draft — replace bracketed figures with Armchair's actuals (downloads, watch-time, audience survey, socials). Live platform: armchair-nfl.vercel.app. Concept for pitch purposes; not affiliated with the NFL, ESPN or Disney+.</a:t>
             </a:r>
             <a:endParaRPr lang="en-US" sz="950" dirty="0"/>
           </a:p>
@@ -3568,6 +2250,1469 @@
 <file path=ppt/slides/slide3.xml><?xml version="1.0" encoding="utf-8"?>
 <p:sld xmlns:a="http://schemas.openxmlformats.org/drawingml/2006/main" xmlns:r="http://schemas.openxmlformats.org/officeDocument/2006/relationships" xmlns:p="http://schemas.openxmlformats.org/presentationml/2006/main">
   <p:cSld name="Slide 3">
+    <p:bg>
+      <p:bgPr>
+        <a:solidFill>
+          <a:srgbClr val="0F0407"/>
+        </a:solidFill>
+      </p:bgPr>
+    </p:bg>
+    <p:spTree>
+      <p:nvGrpSpPr>
+        <p:cNvPr id="1" name=""/>
+        <p:cNvGrpSpPr/>
+        <p:nvPr/>
+      </p:nvGrpSpPr>
+      <p:grpSpPr>
+        <a:xfrm>
+          <a:off x="0" y="0"/>
+          <a:ext cx="0" cy="0"/>
+          <a:chOff x="0" y="0"/>
+          <a:chExt cx="0" cy="0"/>
+        </a:xfrm>
+      </p:grpSpPr>
+      <p:sp>
+        <p:nvSpPr>
+          <p:cNvPr id="2" name="Text 0"/>
+          <p:cNvSpPr/>
+          <p:nvPr/>
+        </p:nvSpPr>
+        <p:spPr>
+          <a:xfrm>
+            <a:off x="8074152" y="384048"/>
+            <a:ext cx="3657600" cy="274320"/>
+          </a:xfrm>
+          <a:prstGeom prst="rect">
+            <a:avLst/>
+          </a:prstGeom>
+          <a:noFill/>
+          <a:ln/>
+        </p:spPr>
+        <p:txBody>
+          <a:bodyPr wrap="square" lIns="0" tIns="0" rIns="0" bIns="0" rtlCol="0" anchor="ctr"/>
+          <a:lstStyle/>
+          <a:p>
+            <a:pPr algn="r" indent="0" marL="0">
+              <a:buNone/>
+            </a:pPr>
+            <a:r>
+              <a:rPr lang="en-US" sz="1400" b="1" dirty="0">
+                <a:solidFill>
+                  <a:srgbClr val="F9F3F5"/>
+                </a:solidFill>
+                <a:latin typeface="Arial Narrow" pitchFamily="34" charset="0"/>
+                <a:ea typeface="Arial Narrow" pitchFamily="34" charset="-122"/>
+                <a:cs typeface="Arial Narrow" pitchFamily="34" charset="-120"/>
+              </a:rPr>
+              <a:t>Armchair</a:t>
+            </a:r>
+            <a:pPr algn="r" indent="0" marL="0">
+              <a:buNone/>
+            </a:pPr>
+            <a:r>
+              <a:rPr lang="en-US" sz="1400" b="1" dirty="0">
+                <a:solidFill>
+                  <a:srgbClr val="F5294B"/>
+                </a:solidFill>
+                <a:latin typeface="Arial Narrow" pitchFamily="34" charset="0"/>
+                <a:ea typeface="Arial Narrow" pitchFamily="34" charset="-122"/>
+                <a:cs typeface="Arial Narrow" pitchFamily="34" charset="-120"/>
+              </a:rPr>
+              <a:t>·</a:t>
+            </a:r>
+            <a:pPr algn="r" indent="0" marL="0">
+              <a:buNone/>
+            </a:pPr>
+            <a:r>
+              <a:rPr lang="en-US" sz="1400" b="1" dirty="0">
+                <a:solidFill>
+                  <a:srgbClr val="F9F3F5"/>
+                </a:solidFill>
+                <a:latin typeface="Arial Narrow" pitchFamily="34" charset="0"/>
+                <a:ea typeface="Arial Narrow" pitchFamily="34" charset="-122"/>
+                <a:cs typeface="Arial Narrow" pitchFamily="34" charset="-120"/>
+              </a:rPr>
+              <a:t>Experts</a:t>
+            </a:r>
+            <a:endParaRPr lang="en-US" sz="1400" dirty="0"/>
+          </a:p>
+        </p:txBody>
+      </p:sp>
+      <p:sp>
+        <p:nvSpPr>
+          <p:cNvPr id="3" name="Text 1"/>
+          <p:cNvSpPr/>
+          <p:nvPr/>
+        </p:nvSpPr>
+        <p:spPr>
+          <a:xfrm>
+            <a:off x="8074152" y="676656"/>
+            <a:ext cx="3657600" cy="228600"/>
+          </a:xfrm>
+          <a:prstGeom prst="rect">
+            <a:avLst/>
+          </a:prstGeom>
+          <a:noFill/>
+          <a:ln/>
+        </p:spPr>
+        <p:txBody>
+          <a:bodyPr wrap="square" lIns="0" tIns="0" rIns="0" bIns="0" rtlCol="0" anchor="ctr"/>
+          <a:lstStyle/>
+          <a:p>
+            <a:pPr algn="r" indent="0" marL="0">
+              <a:buNone/>
+            </a:pPr>
+            <a:r>
+              <a:rPr lang="en-US" sz="950" spc="100" kern="0" dirty="0">
+                <a:solidFill>
+                  <a:srgbClr val="A57E8B"/>
+                </a:solidFill>
+                <a:latin typeface="Arial" pitchFamily="34" charset="0"/>
+                <a:ea typeface="Arial" pitchFamily="34" charset="-122"/>
+                <a:cs typeface="Arial" pitchFamily="34" charset="-120"/>
+              </a:rPr>
+              <a:t>STREAMING PARTNER · </a:t>
+            </a:r>
+            <a:pPr algn="r" indent="0" marL="0">
+              <a:buNone/>
+            </a:pPr>
+            <a:r>
+              <a:rPr lang="en-US" sz="950" b="1" spc="100" kern="0" dirty="0">
+                <a:solidFill>
+                  <a:srgbClr val="5AA7FF"/>
+                </a:solidFill>
+                <a:latin typeface="Arial" pitchFamily="34" charset="0"/>
+                <a:ea typeface="Arial" pitchFamily="34" charset="-122"/>
+                <a:cs typeface="Arial" pitchFamily="34" charset="-120"/>
+              </a:rPr>
+              <a:t>Disney+</a:t>
+            </a:r>
+            <a:endParaRPr lang="en-US" sz="950" dirty="0"/>
+          </a:p>
+        </p:txBody>
+      </p:sp>
+      <p:sp>
+        <p:nvSpPr>
+          <p:cNvPr id="4" name="Text 2"/>
+          <p:cNvSpPr/>
+          <p:nvPr/>
+        </p:nvSpPr>
+        <p:spPr>
+          <a:xfrm>
+            <a:off x="457200" y="457200"/>
+            <a:ext cx="7315200" cy="274320"/>
+          </a:xfrm>
+          <a:prstGeom prst="rect">
+            <a:avLst/>
+          </a:prstGeom>
+          <a:noFill/>
+          <a:ln/>
+        </p:spPr>
+        <p:txBody>
+          <a:bodyPr wrap="square" lIns="0" tIns="0" rIns="0" bIns="0" rtlCol="0" anchor="ctr"/>
+          <a:lstStyle/>
+          <a:p>
+            <a:pPr indent="0" marL="0">
+              <a:buNone/>
+            </a:pPr>
+            <a:r>
+              <a:rPr lang="en-US" sz="1100" b="1" spc="300" kern="0" dirty="0">
+                <a:solidFill>
+                  <a:srgbClr val="F5294B"/>
+                </a:solidFill>
+                <a:latin typeface="Arial" pitchFamily="34" charset="0"/>
+                <a:ea typeface="Arial" pitchFamily="34" charset="-122"/>
+                <a:cs typeface="Arial" pitchFamily="34" charset="-120"/>
+              </a:rPr>
+              <a:t>THE PROOF</a:t>
+            </a:r>
+            <a:endParaRPr lang="en-US" sz="1100" dirty="0"/>
+          </a:p>
+        </p:txBody>
+      </p:sp>
+      <p:sp>
+        <p:nvSpPr>
+          <p:cNvPr id="5" name="Text 3"/>
+          <p:cNvSpPr/>
+          <p:nvPr/>
+        </p:nvSpPr>
+        <p:spPr>
+          <a:xfrm>
+            <a:off x="438912" y="749808"/>
+            <a:ext cx="8412480" cy="1143000"/>
+          </a:xfrm>
+          <a:prstGeom prst="rect">
+            <a:avLst/>
+          </a:prstGeom>
+          <a:noFill/>
+          <a:ln/>
+        </p:spPr>
+        <p:txBody>
+          <a:bodyPr wrap="square" lIns="0" tIns="0" rIns="0" bIns="0" rtlCol="0" anchor="t"/>
+          <a:lstStyle/>
+          <a:p>
+            <a:pPr indent="0" marL="0">
+              <a:lnSpc>
+                <a:spcPct val="95000"/>
+              </a:lnSpc>
+              <a:buNone/>
+            </a:pPr>
+            <a:r>
+              <a:rPr lang="en-US" sz="4100" b="1" dirty="0">
+                <a:solidFill>
+                  <a:srgbClr val="F9F3F5"/>
+                </a:solidFill>
+                <a:latin typeface="Arial Narrow" pitchFamily="34" charset="0"/>
+                <a:ea typeface="Arial Narrow" pitchFamily="34" charset="-122"/>
+                <a:cs typeface="Arial Narrow" pitchFamily="34" charset="-120"/>
+              </a:rPr>
+              <a:t>How we prove it drove subscriptions</a:t>
+            </a:r>
+            <a:endParaRPr lang="en-US" sz="4100" dirty="0"/>
+          </a:p>
+        </p:txBody>
+      </p:sp>
+      <p:sp>
+        <p:nvSpPr>
+          <p:cNvPr id="6" name="Text 4"/>
+          <p:cNvSpPr/>
+          <p:nvPr/>
+        </p:nvSpPr>
+        <p:spPr>
+          <a:xfrm>
+            <a:off x="457200" y="1938528"/>
+            <a:ext cx="7680960" cy="640080"/>
+          </a:xfrm>
+          <a:prstGeom prst="rect">
+            <a:avLst/>
+          </a:prstGeom>
+          <a:noFill/>
+          <a:ln/>
+        </p:spPr>
+        <p:txBody>
+          <a:bodyPr wrap="square" lIns="0" tIns="0" rIns="0" bIns="0" rtlCol="0" anchor="t"/>
+          <a:lstStyle/>
+          <a:p>
+            <a:pPr indent="0" marL="0">
+              <a:lnSpc>
+                <a:spcPct val="105000"/>
+              </a:lnSpc>
+              <a:buNone/>
+            </a:pPr>
+            <a:r>
+              <a:rPr lang="en-US" sz="1400" dirty="0">
+                <a:solidFill>
+                  <a:srgbClr val="DCC3CB"/>
+                </a:solidFill>
+                <a:latin typeface="Arial" pitchFamily="34" charset="0"/>
+                <a:ea typeface="Arial" pitchFamily="34" charset="-122"/>
+                <a:cs typeface="Arial" pitchFamily="34" charset="-120"/>
+              </a:rPr>
+              <a:t>Turning “awareness” into a number Disney+ can bank — one tracked path from a mention to a sign-up.</a:t>
+            </a:r>
+            <a:endParaRPr lang="en-US" sz="1400" dirty="0"/>
+          </a:p>
+        </p:txBody>
+      </p:sp>
+      <p:sp>
+        <p:nvSpPr>
+          <p:cNvPr id="7" name="Shape 5"/>
+          <p:cNvSpPr/>
+          <p:nvPr/>
+        </p:nvSpPr>
+        <p:spPr>
+          <a:xfrm>
+            <a:off x="457200" y="2697480"/>
+            <a:ext cx="2695194" cy="1847088"/>
+          </a:xfrm>
+          <a:prstGeom prst="roundRect">
+            <a:avLst>
+              <a:gd name="adj" fmla="val 4455"/>
+            </a:avLst>
+          </a:prstGeom>
+          <a:solidFill>
+            <a:srgbClr val="1E0C13"/>
+          </a:solidFill>
+          <a:ln w="12700">
+            <a:solidFill>
+              <a:srgbClr val="43202C"/>
+            </a:solidFill>
+            <a:prstDash val="solid"/>
+          </a:ln>
+        </p:spPr>
+      </p:sp>
+      <p:sp>
+        <p:nvSpPr>
+          <p:cNvPr id="8" name="Text 6"/>
+          <p:cNvSpPr/>
+          <p:nvPr/>
+        </p:nvSpPr>
+        <p:spPr>
+          <a:xfrm>
+            <a:off x="603504" y="2825496"/>
+            <a:ext cx="2402586" cy="1170432"/>
+          </a:xfrm>
+          <a:prstGeom prst="rect">
+            <a:avLst/>
+          </a:prstGeom>
+          <a:noFill/>
+          <a:ln/>
+        </p:spPr>
+        <p:txBody>
+          <a:bodyPr wrap="square" lIns="0" tIns="0" rIns="0" bIns="0" rtlCol="0" anchor="t"/>
+          <a:lstStyle/>
+          <a:p>
+            <a:pPr indent="0" marL="0">
+              <a:lnSpc>
+                <a:spcPct val="100000"/>
+              </a:lnSpc>
+              <a:buNone/>
+            </a:pPr>
+            <a:r>
+              <a:rPr lang="en-US" sz="1600" b="1" spc="200" kern="0" dirty="0">
+                <a:solidFill>
+                  <a:srgbClr val="F5294B"/>
+                </a:solidFill>
+                <a:latin typeface="Arial Narrow" pitchFamily="34" charset="0"/>
+                <a:ea typeface="Arial Narrow" pitchFamily="34" charset="-122"/>
+                <a:cs typeface="Arial Narrow" pitchFamily="34" charset="-120"/>
+              </a:rPr>
+              <a:t>01</a:t>
+            </a:r>
+            <a:endParaRPr lang="en-US" sz="1600" dirty="0"/>
+          </a:p>
+          <a:p>
+            <a:pPr indent="0" marL="0">
+              <a:lnSpc>
+                <a:spcPct val="100000"/>
+              </a:lnSpc>
+              <a:spcBef>
+                <a:spcPts val="300"/>
+              </a:spcBef>
+              <a:buNone/>
+            </a:pPr>
+            <a:r>
+              <a:rPr lang="en-US" sz="1600" b="1" spc="50" kern="0" dirty="0">
+                <a:solidFill>
+                  <a:srgbClr val="F9F3F5"/>
+                </a:solidFill>
+                <a:latin typeface="Arial Narrow" pitchFamily="34" charset="0"/>
+                <a:ea typeface="Arial Narrow" pitchFamily="34" charset="-122"/>
+                <a:cs typeface="Arial Narrow" pitchFamily="34" charset="-120"/>
+              </a:rPr>
+              <a:t>Awareness</a:t>
+            </a:r>
+            <a:endParaRPr lang="en-US" sz="1600" dirty="0"/>
+          </a:p>
+          <a:p>
+            <a:pPr indent="0" marL="0">
+              <a:lnSpc>
+                <a:spcPct val="100000"/>
+              </a:lnSpc>
+              <a:spcBef>
+                <a:spcPts val="600"/>
+              </a:spcBef>
+              <a:buNone/>
+            </a:pPr>
+            <a:r>
+              <a:rPr lang="en-US" sz="950" dirty="0">
+                <a:solidFill>
+                  <a:srgbClr val="DCC3CB"/>
+                </a:solidFill>
+                <a:latin typeface="Arial" pitchFamily="34" charset="0"/>
+                <a:ea typeface="Arial" pitchFamily="34" charset="-122"/>
+                <a:cs typeface="Arial" pitchFamily="34" charset="-120"/>
+              </a:rPr>
+              <a:t>Show, social &amp; the iHeart network put the NFL story in front of fans.</a:t>
+            </a:r>
+            <a:endParaRPr lang="en-US" sz="1600" dirty="0"/>
+          </a:p>
+        </p:txBody>
+      </p:sp>
+      <p:sp>
+        <p:nvSpPr>
+          <p:cNvPr id="9" name="Text 7"/>
+          <p:cNvSpPr/>
+          <p:nvPr/>
+        </p:nvSpPr>
+        <p:spPr>
+          <a:xfrm>
+            <a:off x="603504" y="3977640"/>
+            <a:ext cx="2402586" cy="457200"/>
+          </a:xfrm>
+          <a:prstGeom prst="rect">
+            <a:avLst/>
+          </a:prstGeom>
+          <a:noFill/>
+          <a:ln/>
+        </p:spPr>
+        <p:txBody>
+          <a:bodyPr wrap="square" lIns="0" tIns="0" rIns="0" bIns="0" rtlCol="0" anchor="t"/>
+          <a:lstStyle/>
+          <a:p>
+            <a:pPr indent="0" marL="0">
+              <a:buNone/>
+            </a:pPr>
+            <a:r>
+              <a:rPr lang="en-US" sz="800" spc="150" kern="0" dirty="0">
+                <a:solidFill>
+                  <a:srgbClr val="A57E8B"/>
+                </a:solidFill>
+                <a:latin typeface="Arial" pitchFamily="34" charset="0"/>
+                <a:ea typeface="Arial" pitchFamily="34" charset="-122"/>
+                <a:cs typeface="Arial" pitchFamily="34" charset="-120"/>
+              </a:rPr>
+              <a:t>MEASURED BY</a:t>
+            </a:r>
+            <a:endParaRPr lang="en-US" sz="800" dirty="0"/>
+          </a:p>
+          <a:p>
+            <a:pPr indent="0" marL="0">
+              <a:spcBef>
+                <a:spcPts val="200"/>
+              </a:spcBef>
+              <a:buNone/>
+            </a:pPr>
+            <a:r>
+              <a:rPr lang="en-US" sz="1150" b="1" dirty="0">
+                <a:solidFill>
+                  <a:srgbClr val="43C58C"/>
+                </a:solidFill>
+                <a:latin typeface="Arial" pitchFamily="34" charset="0"/>
+                <a:ea typeface="Arial" pitchFamily="34" charset="-122"/>
+                <a:cs typeface="Arial" pitchFamily="34" charset="-120"/>
+              </a:rPr>
+              <a:t>Reach &amp; impressions</a:t>
+            </a:r>
+            <a:endParaRPr lang="en-US" sz="800" dirty="0"/>
+          </a:p>
+        </p:txBody>
+      </p:sp>
+      <p:sp>
+        <p:nvSpPr>
+          <p:cNvPr id="10" name="Text 8"/>
+          <p:cNvSpPr/>
+          <p:nvPr/>
+        </p:nvSpPr>
+        <p:spPr>
+          <a:xfrm>
+            <a:off x="3134106" y="3364992"/>
+            <a:ext cx="201168" cy="457200"/>
+          </a:xfrm>
+          <a:prstGeom prst="rect">
+            <a:avLst/>
+          </a:prstGeom>
+          <a:noFill/>
+          <a:ln/>
+        </p:spPr>
+        <p:txBody>
+          <a:bodyPr wrap="square" lIns="0" tIns="0" rIns="0" bIns="0" rtlCol="0" anchor="ctr"/>
+          <a:lstStyle/>
+          <a:p>
+            <a:pPr algn="ctr" indent="0" marL="0">
+              <a:buNone/>
+            </a:pPr>
+            <a:r>
+              <a:rPr lang="en-US" sz="2000" b="1" dirty="0">
+                <a:solidFill>
+                  <a:srgbClr val="A57E8B"/>
+                </a:solidFill>
+                <a:latin typeface="Arial" pitchFamily="34" charset="0"/>
+                <a:ea typeface="Arial" pitchFamily="34" charset="-122"/>
+                <a:cs typeface="Arial" pitchFamily="34" charset="-120"/>
+              </a:rPr>
+              <a:t>›</a:t>
+            </a:r>
+            <a:endParaRPr lang="en-US" sz="2000" dirty="0"/>
+          </a:p>
+        </p:txBody>
+      </p:sp>
+      <p:sp>
+        <p:nvSpPr>
+          <p:cNvPr id="11" name="Shape 9"/>
+          <p:cNvSpPr/>
+          <p:nvPr/>
+        </p:nvSpPr>
+        <p:spPr>
+          <a:xfrm>
+            <a:off x="3316986" y="2697480"/>
+            <a:ext cx="2695194" cy="1847088"/>
+          </a:xfrm>
+          <a:prstGeom prst="roundRect">
+            <a:avLst>
+              <a:gd name="adj" fmla="val 4455"/>
+            </a:avLst>
+          </a:prstGeom>
+          <a:solidFill>
+            <a:srgbClr val="1E0C13"/>
+          </a:solidFill>
+          <a:ln w="12700">
+            <a:solidFill>
+              <a:srgbClr val="43202C"/>
+            </a:solidFill>
+            <a:prstDash val="solid"/>
+          </a:ln>
+        </p:spPr>
+      </p:sp>
+      <p:sp>
+        <p:nvSpPr>
+          <p:cNvPr id="12" name="Text 10"/>
+          <p:cNvSpPr/>
+          <p:nvPr/>
+        </p:nvSpPr>
+        <p:spPr>
+          <a:xfrm>
+            <a:off x="3463290" y="2825496"/>
+            <a:ext cx="2402586" cy="1170432"/>
+          </a:xfrm>
+          <a:prstGeom prst="rect">
+            <a:avLst/>
+          </a:prstGeom>
+          <a:noFill/>
+          <a:ln/>
+        </p:spPr>
+        <p:txBody>
+          <a:bodyPr wrap="square" lIns="0" tIns="0" rIns="0" bIns="0" rtlCol="0" anchor="t"/>
+          <a:lstStyle/>
+          <a:p>
+            <a:pPr indent="0" marL="0">
+              <a:lnSpc>
+                <a:spcPct val="100000"/>
+              </a:lnSpc>
+              <a:buNone/>
+            </a:pPr>
+            <a:r>
+              <a:rPr lang="en-US" sz="1600" b="1" spc="200" kern="0" dirty="0">
+                <a:solidFill>
+                  <a:srgbClr val="F5294B"/>
+                </a:solidFill>
+                <a:latin typeface="Arial Narrow" pitchFamily="34" charset="0"/>
+                <a:ea typeface="Arial Narrow" pitchFamily="34" charset="-122"/>
+                <a:cs typeface="Arial Narrow" pitchFamily="34" charset="-120"/>
+              </a:rPr>
+              <a:t>02</a:t>
+            </a:r>
+            <a:endParaRPr lang="en-US" sz="1600" dirty="0"/>
+          </a:p>
+          <a:p>
+            <a:pPr indent="0" marL="0">
+              <a:lnSpc>
+                <a:spcPct val="100000"/>
+              </a:lnSpc>
+              <a:spcBef>
+                <a:spcPts val="300"/>
+              </a:spcBef>
+              <a:buNone/>
+            </a:pPr>
+            <a:r>
+              <a:rPr lang="en-US" sz="1600" b="1" spc="50" kern="0" dirty="0">
+                <a:solidFill>
+                  <a:srgbClr val="F9F3F5"/>
+                </a:solidFill>
+                <a:latin typeface="Arial Narrow" pitchFamily="34" charset="0"/>
+                <a:ea typeface="Arial Narrow" pitchFamily="34" charset="-122"/>
+                <a:cs typeface="Arial Narrow" pitchFamily="34" charset="-120"/>
+              </a:rPr>
+              <a:t>Intent</a:t>
+            </a:r>
+            <a:endParaRPr lang="en-US" sz="1600" dirty="0"/>
+          </a:p>
+          <a:p>
+            <a:pPr indent="0" marL="0">
+              <a:lnSpc>
+                <a:spcPct val="100000"/>
+              </a:lnSpc>
+              <a:spcBef>
+                <a:spcPts val="600"/>
+              </a:spcBef>
+              <a:buNone/>
+            </a:pPr>
+            <a:r>
+              <a:rPr lang="en-US" sz="950" dirty="0">
+                <a:solidFill>
+                  <a:srgbClr val="DCC3CB"/>
+                </a:solidFill>
+                <a:latin typeface="Arial" pitchFamily="34" charset="0"/>
+                <a:ea typeface="Arial" pitchFamily="34" charset="-122"/>
+                <a:cs typeface="Arial" pitchFamily="34" charset="-120"/>
+              </a:rPr>
+              <a:t>A unique tracked deep-link &amp; on-air promo code in every episode.</a:t>
+            </a:r>
+            <a:endParaRPr lang="en-US" sz="1600" dirty="0"/>
+          </a:p>
+        </p:txBody>
+      </p:sp>
+      <p:sp>
+        <p:nvSpPr>
+          <p:cNvPr id="13" name="Text 11"/>
+          <p:cNvSpPr/>
+          <p:nvPr/>
+        </p:nvSpPr>
+        <p:spPr>
+          <a:xfrm>
+            <a:off x="3463290" y="3977640"/>
+            <a:ext cx="2402586" cy="457200"/>
+          </a:xfrm>
+          <a:prstGeom prst="rect">
+            <a:avLst/>
+          </a:prstGeom>
+          <a:noFill/>
+          <a:ln/>
+        </p:spPr>
+        <p:txBody>
+          <a:bodyPr wrap="square" lIns="0" tIns="0" rIns="0" bIns="0" rtlCol="0" anchor="t"/>
+          <a:lstStyle/>
+          <a:p>
+            <a:pPr indent="0" marL="0">
+              <a:buNone/>
+            </a:pPr>
+            <a:r>
+              <a:rPr lang="en-US" sz="800" spc="150" kern="0" dirty="0">
+                <a:solidFill>
+                  <a:srgbClr val="A57E8B"/>
+                </a:solidFill>
+                <a:latin typeface="Arial" pitchFamily="34" charset="0"/>
+                <a:ea typeface="Arial" pitchFamily="34" charset="-122"/>
+                <a:cs typeface="Arial" pitchFamily="34" charset="-120"/>
+              </a:rPr>
+              <a:t>MEASURED BY</a:t>
+            </a:r>
+            <a:endParaRPr lang="en-US" sz="800" dirty="0"/>
+          </a:p>
+          <a:p>
+            <a:pPr indent="0" marL="0">
+              <a:spcBef>
+                <a:spcPts val="200"/>
+              </a:spcBef>
+              <a:buNone/>
+            </a:pPr>
+            <a:r>
+              <a:rPr lang="en-US" sz="1150" b="1" dirty="0">
+                <a:solidFill>
+                  <a:srgbClr val="43C58C"/>
+                </a:solidFill>
+                <a:latin typeface="Arial" pitchFamily="34" charset="0"/>
+                <a:ea typeface="Arial" pitchFamily="34" charset="-122"/>
+                <a:cs typeface="Arial" pitchFamily="34" charset="-120"/>
+              </a:rPr>
+              <a:t>Click-through rate</a:t>
+            </a:r>
+            <a:endParaRPr lang="en-US" sz="800" dirty="0"/>
+          </a:p>
+        </p:txBody>
+      </p:sp>
+      <p:sp>
+        <p:nvSpPr>
+          <p:cNvPr id="14" name="Text 12"/>
+          <p:cNvSpPr/>
+          <p:nvPr/>
+        </p:nvSpPr>
+        <p:spPr>
+          <a:xfrm>
+            <a:off x="5993892" y="3364992"/>
+            <a:ext cx="201168" cy="457200"/>
+          </a:xfrm>
+          <a:prstGeom prst="rect">
+            <a:avLst/>
+          </a:prstGeom>
+          <a:noFill/>
+          <a:ln/>
+        </p:spPr>
+        <p:txBody>
+          <a:bodyPr wrap="square" lIns="0" tIns="0" rIns="0" bIns="0" rtlCol="0" anchor="ctr"/>
+          <a:lstStyle/>
+          <a:p>
+            <a:pPr algn="ctr" indent="0" marL="0">
+              <a:buNone/>
+            </a:pPr>
+            <a:r>
+              <a:rPr lang="en-US" sz="2000" b="1" dirty="0">
+                <a:solidFill>
+                  <a:srgbClr val="A57E8B"/>
+                </a:solidFill>
+                <a:latin typeface="Arial" pitchFamily="34" charset="0"/>
+                <a:ea typeface="Arial" pitchFamily="34" charset="-122"/>
+                <a:cs typeface="Arial" pitchFamily="34" charset="-120"/>
+              </a:rPr>
+              <a:t>›</a:t>
+            </a:r>
+            <a:endParaRPr lang="en-US" sz="2000" dirty="0"/>
+          </a:p>
+        </p:txBody>
+      </p:sp>
+      <p:sp>
+        <p:nvSpPr>
+          <p:cNvPr id="15" name="Shape 13"/>
+          <p:cNvSpPr/>
+          <p:nvPr/>
+        </p:nvSpPr>
+        <p:spPr>
+          <a:xfrm>
+            <a:off x="6176772" y="2697480"/>
+            <a:ext cx="2695194" cy="1847088"/>
+          </a:xfrm>
+          <a:prstGeom prst="roundRect">
+            <a:avLst>
+              <a:gd name="adj" fmla="val 4455"/>
+            </a:avLst>
+          </a:prstGeom>
+          <a:solidFill>
+            <a:srgbClr val="1E0C13"/>
+          </a:solidFill>
+          <a:ln w="12700">
+            <a:solidFill>
+              <a:srgbClr val="43202C"/>
+            </a:solidFill>
+            <a:prstDash val="solid"/>
+          </a:ln>
+        </p:spPr>
+      </p:sp>
+      <p:sp>
+        <p:nvSpPr>
+          <p:cNvPr id="16" name="Text 14"/>
+          <p:cNvSpPr/>
+          <p:nvPr/>
+        </p:nvSpPr>
+        <p:spPr>
+          <a:xfrm>
+            <a:off x="6323076" y="2825496"/>
+            <a:ext cx="2402586" cy="1170432"/>
+          </a:xfrm>
+          <a:prstGeom prst="rect">
+            <a:avLst/>
+          </a:prstGeom>
+          <a:noFill/>
+          <a:ln/>
+        </p:spPr>
+        <p:txBody>
+          <a:bodyPr wrap="square" lIns="0" tIns="0" rIns="0" bIns="0" rtlCol="0" anchor="t"/>
+          <a:lstStyle/>
+          <a:p>
+            <a:pPr indent="0" marL="0">
+              <a:lnSpc>
+                <a:spcPct val="100000"/>
+              </a:lnSpc>
+              <a:buNone/>
+            </a:pPr>
+            <a:r>
+              <a:rPr lang="en-US" sz="1600" b="1" spc="200" kern="0" dirty="0">
+                <a:solidFill>
+                  <a:srgbClr val="F5294B"/>
+                </a:solidFill>
+                <a:latin typeface="Arial Narrow" pitchFamily="34" charset="0"/>
+                <a:ea typeface="Arial Narrow" pitchFamily="34" charset="-122"/>
+                <a:cs typeface="Arial Narrow" pitchFamily="34" charset="-120"/>
+              </a:rPr>
+              <a:t>03</a:t>
+            </a:r>
+            <a:endParaRPr lang="en-US" sz="1600" dirty="0"/>
+          </a:p>
+          <a:p>
+            <a:pPr indent="0" marL="0">
+              <a:lnSpc>
+                <a:spcPct val="100000"/>
+              </a:lnSpc>
+              <a:spcBef>
+                <a:spcPts val="300"/>
+              </a:spcBef>
+              <a:buNone/>
+            </a:pPr>
+            <a:r>
+              <a:rPr lang="en-US" sz="1600" b="1" spc="50" kern="0" dirty="0">
+                <a:solidFill>
+                  <a:srgbClr val="F9F3F5"/>
+                </a:solidFill>
+                <a:latin typeface="Arial Narrow" pitchFamily="34" charset="0"/>
+                <a:ea typeface="Arial Narrow" pitchFamily="34" charset="-122"/>
+                <a:cs typeface="Arial Narrow" pitchFamily="34" charset="-120"/>
+              </a:rPr>
+              <a:t>Conversion</a:t>
+            </a:r>
+            <a:endParaRPr lang="en-US" sz="1600" dirty="0"/>
+          </a:p>
+          <a:p>
+            <a:pPr indent="0" marL="0">
+              <a:lnSpc>
+                <a:spcPct val="100000"/>
+              </a:lnSpc>
+              <a:spcBef>
+                <a:spcPts val="600"/>
+              </a:spcBef>
+              <a:buNone/>
+            </a:pPr>
+            <a:r>
+              <a:rPr lang="en-US" sz="950" dirty="0">
+                <a:solidFill>
+                  <a:srgbClr val="DCC3CB"/>
+                </a:solidFill>
+                <a:latin typeface="Arial" pitchFamily="34" charset="0"/>
+                <a:ea typeface="Arial" pitchFamily="34" charset="-122"/>
+                <a:cs typeface="Arial" pitchFamily="34" charset="-120"/>
+              </a:rPr>
+              <a:t>A co-branded, code-gated giveaway page captures the referral.</a:t>
+            </a:r>
+            <a:endParaRPr lang="en-US" sz="1600" dirty="0"/>
+          </a:p>
+        </p:txBody>
+      </p:sp>
+      <p:sp>
+        <p:nvSpPr>
+          <p:cNvPr id="17" name="Text 15"/>
+          <p:cNvSpPr/>
+          <p:nvPr/>
+        </p:nvSpPr>
+        <p:spPr>
+          <a:xfrm>
+            <a:off x="6323076" y="3977640"/>
+            <a:ext cx="2402586" cy="457200"/>
+          </a:xfrm>
+          <a:prstGeom prst="rect">
+            <a:avLst/>
+          </a:prstGeom>
+          <a:noFill/>
+          <a:ln/>
+        </p:spPr>
+        <p:txBody>
+          <a:bodyPr wrap="square" lIns="0" tIns="0" rIns="0" bIns="0" rtlCol="0" anchor="t"/>
+          <a:lstStyle/>
+          <a:p>
+            <a:pPr indent="0" marL="0">
+              <a:buNone/>
+            </a:pPr>
+            <a:r>
+              <a:rPr lang="en-US" sz="800" spc="150" kern="0" dirty="0">
+                <a:solidFill>
+                  <a:srgbClr val="A57E8B"/>
+                </a:solidFill>
+                <a:latin typeface="Arial" pitchFamily="34" charset="0"/>
+                <a:ea typeface="Arial" pitchFamily="34" charset="-122"/>
+                <a:cs typeface="Arial" pitchFamily="34" charset="-120"/>
+              </a:rPr>
+              <a:t>MEASURED BY</a:t>
+            </a:r>
+            <a:endParaRPr lang="en-US" sz="800" dirty="0"/>
+          </a:p>
+          <a:p>
+            <a:pPr indent="0" marL="0">
+              <a:spcBef>
+                <a:spcPts val="200"/>
+              </a:spcBef>
+              <a:buNone/>
+            </a:pPr>
+            <a:r>
+              <a:rPr lang="en-US" sz="1150" b="1" dirty="0">
+                <a:solidFill>
+                  <a:srgbClr val="43C58C"/>
+                </a:solidFill>
+                <a:latin typeface="Arial" pitchFamily="34" charset="0"/>
+                <a:ea typeface="Arial" pitchFamily="34" charset="-122"/>
+                <a:cs typeface="Arial" pitchFamily="34" charset="-120"/>
+              </a:rPr>
+              <a:t>Attributed sign-ups</a:t>
+            </a:r>
+            <a:endParaRPr lang="en-US" sz="800" dirty="0"/>
+          </a:p>
+        </p:txBody>
+      </p:sp>
+      <p:sp>
+        <p:nvSpPr>
+          <p:cNvPr id="18" name="Text 16"/>
+          <p:cNvSpPr/>
+          <p:nvPr/>
+        </p:nvSpPr>
+        <p:spPr>
+          <a:xfrm>
+            <a:off x="8853678" y="3364992"/>
+            <a:ext cx="201168" cy="457200"/>
+          </a:xfrm>
+          <a:prstGeom prst="rect">
+            <a:avLst/>
+          </a:prstGeom>
+          <a:noFill/>
+          <a:ln/>
+        </p:spPr>
+        <p:txBody>
+          <a:bodyPr wrap="square" lIns="0" tIns="0" rIns="0" bIns="0" rtlCol="0" anchor="ctr"/>
+          <a:lstStyle/>
+          <a:p>
+            <a:pPr algn="ctr" indent="0" marL="0">
+              <a:buNone/>
+            </a:pPr>
+            <a:r>
+              <a:rPr lang="en-US" sz="2000" b="1" dirty="0">
+                <a:solidFill>
+                  <a:srgbClr val="A57E8B"/>
+                </a:solidFill>
+                <a:latin typeface="Arial" pitchFamily="34" charset="0"/>
+                <a:ea typeface="Arial" pitchFamily="34" charset="-122"/>
+                <a:cs typeface="Arial" pitchFamily="34" charset="-120"/>
+              </a:rPr>
+              <a:t>›</a:t>
+            </a:r>
+            <a:endParaRPr lang="en-US" sz="2000" dirty="0"/>
+          </a:p>
+        </p:txBody>
+      </p:sp>
+      <p:sp>
+        <p:nvSpPr>
+          <p:cNvPr id="19" name="Shape 17"/>
+          <p:cNvSpPr/>
+          <p:nvPr/>
+        </p:nvSpPr>
+        <p:spPr>
+          <a:xfrm>
+            <a:off x="9036558" y="2697480"/>
+            <a:ext cx="2695194" cy="1847088"/>
+          </a:xfrm>
+          <a:prstGeom prst="roundRect">
+            <a:avLst>
+              <a:gd name="adj" fmla="val 4455"/>
+            </a:avLst>
+          </a:prstGeom>
+          <a:solidFill>
+            <a:srgbClr val="1E0C13"/>
+          </a:solidFill>
+          <a:ln w="12700">
+            <a:solidFill>
+              <a:srgbClr val="43202C"/>
+            </a:solidFill>
+            <a:prstDash val="solid"/>
+          </a:ln>
+        </p:spPr>
+      </p:sp>
+      <p:sp>
+        <p:nvSpPr>
+          <p:cNvPr id="20" name="Text 18"/>
+          <p:cNvSpPr/>
+          <p:nvPr/>
+        </p:nvSpPr>
+        <p:spPr>
+          <a:xfrm>
+            <a:off x="9182862" y="2825496"/>
+            <a:ext cx="2402586" cy="1170432"/>
+          </a:xfrm>
+          <a:prstGeom prst="rect">
+            <a:avLst/>
+          </a:prstGeom>
+          <a:noFill/>
+          <a:ln/>
+        </p:spPr>
+        <p:txBody>
+          <a:bodyPr wrap="square" lIns="0" tIns="0" rIns="0" bIns="0" rtlCol="0" anchor="t"/>
+          <a:lstStyle/>
+          <a:p>
+            <a:pPr indent="0" marL="0">
+              <a:lnSpc>
+                <a:spcPct val="100000"/>
+              </a:lnSpc>
+              <a:buNone/>
+            </a:pPr>
+            <a:r>
+              <a:rPr lang="en-US" sz="1600" b="1" spc="200" kern="0" dirty="0">
+                <a:solidFill>
+                  <a:srgbClr val="F5294B"/>
+                </a:solidFill>
+                <a:latin typeface="Arial Narrow" pitchFamily="34" charset="0"/>
+                <a:ea typeface="Arial Narrow" pitchFamily="34" charset="-122"/>
+                <a:cs typeface="Arial Narrow" pitchFamily="34" charset="-120"/>
+              </a:rPr>
+              <a:t>04</a:t>
+            </a:r>
+            <a:endParaRPr lang="en-US" sz="1600" dirty="0"/>
+          </a:p>
+          <a:p>
+            <a:pPr indent="0" marL="0">
+              <a:lnSpc>
+                <a:spcPct val="100000"/>
+              </a:lnSpc>
+              <a:spcBef>
+                <a:spcPts val="300"/>
+              </a:spcBef>
+              <a:buNone/>
+            </a:pPr>
+            <a:r>
+              <a:rPr lang="en-US" sz="1600" b="1" spc="50" kern="0" dirty="0">
+                <a:solidFill>
+                  <a:srgbClr val="F9F3F5"/>
+                </a:solidFill>
+                <a:latin typeface="Arial Narrow" pitchFamily="34" charset="0"/>
+                <a:ea typeface="Arial Narrow" pitchFamily="34" charset="-122"/>
+                <a:cs typeface="Arial Narrow" pitchFamily="34" charset="-120"/>
+              </a:rPr>
+              <a:t>Prove it</a:t>
+            </a:r>
+            <a:endParaRPr lang="en-US" sz="1600" dirty="0"/>
+          </a:p>
+          <a:p>
+            <a:pPr indent="0" marL="0">
+              <a:lnSpc>
+                <a:spcPct val="100000"/>
+              </a:lnSpc>
+              <a:spcBef>
+                <a:spcPts val="600"/>
+              </a:spcBef>
+              <a:buNone/>
+            </a:pPr>
+            <a:r>
+              <a:rPr lang="en-US" sz="950" dirty="0">
+                <a:solidFill>
+                  <a:srgbClr val="DCC3CB"/>
+                </a:solidFill>
+                <a:latin typeface="Arial" pitchFamily="34" charset="0"/>
+                <a:ea typeface="Arial" pitchFamily="34" charset="-122"/>
+                <a:cs typeface="Arial" pitchFamily="34" charset="-120"/>
+              </a:rPr>
+              <a:t>A shared dashboard reconciles spend against sign-ups fortnightly.</a:t>
+            </a:r>
+            <a:endParaRPr lang="en-US" sz="1600" dirty="0"/>
+          </a:p>
+        </p:txBody>
+      </p:sp>
+      <p:sp>
+        <p:nvSpPr>
+          <p:cNvPr id="21" name="Text 19"/>
+          <p:cNvSpPr/>
+          <p:nvPr/>
+        </p:nvSpPr>
+        <p:spPr>
+          <a:xfrm>
+            <a:off x="9182862" y="3977640"/>
+            <a:ext cx="2402586" cy="457200"/>
+          </a:xfrm>
+          <a:prstGeom prst="rect">
+            <a:avLst/>
+          </a:prstGeom>
+          <a:noFill/>
+          <a:ln/>
+        </p:spPr>
+        <p:txBody>
+          <a:bodyPr wrap="square" lIns="0" tIns="0" rIns="0" bIns="0" rtlCol="0" anchor="t"/>
+          <a:lstStyle/>
+          <a:p>
+            <a:pPr indent="0" marL="0">
+              <a:buNone/>
+            </a:pPr>
+            <a:r>
+              <a:rPr lang="en-US" sz="800" spc="150" kern="0" dirty="0">
+                <a:solidFill>
+                  <a:srgbClr val="A57E8B"/>
+                </a:solidFill>
+                <a:latin typeface="Arial" pitchFamily="34" charset="0"/>
+                <a:ea typeface="Arial" pitchFamily="34" charset="-122"/>
+                <a:cs typeface="Arial" pitchFamily="34" charset="-120"/>
+              </a:rPr>
+              <a:t>MEASURED BY</a:t>
+            </a:r>
+            <a:endParaRPr lang="en-US" sz="800" dirty="0"/>
+          </a:p>
+          <a:p>
+            <a:pPr indent="0" marL="0">
+              <a:spcBef>
+                <a:spcPts val="200"/>
+              </a:spcBef>
+              <a:buNone/>
+            </a:pPr>
+            <a:r>
+              <a:rPr lang="en-US" sz="1150" b="1" dirty="0">
+                <a:solidFill>
+                  <a:srgbClr val="43C58C"/>
+                </a:solidFill>
+                <a:latin typeface="Arial" pitchFamily="34" charset="0"/>
+                <a:ea typeface="Arial" pitchFamily="34" charset="-122"/>
+                <a:cs typeface="Arial" pitchFamily="34" charset="-120"/>
+              </a:rPr>
+              <a:t>Cost per acquisition</a:t>
+            </a:r>
+            <a:endParaRPr lang="en-US" sz="800" dirty="0"/>
+          </a:p>
+        </p:txBody>
+      </p:sp>
+      <p:sp>
+        <p:nvSpPr>
+          <p:cNvPr id="22" name="Shape 20"/>
+          <p:cNvSpPr/>
+          <p:nvPr/>
+        </p:nvSpPr>
+        <p:spPr>
+          <a:xfrm>
+            <a:off x="457200" y="4681728"/>
+            <a:ext cx="6537960" cy="1572768"/>
+          </a:xfrm>
+          <a:prstGeom prst="roundRect">
+            <a:avLst>
+              <a:gd name="adj" fmla="val 5233"/>
+            </a:avLst>
+          </a:prstGeom>
+          <a:solidFill>
+            <a:srgbClr val="1E0C13"/>
+          </a:solidFill>
+          <a:ln w="12700">
+            <a:solidFill>
+              <a:srgbClr val="43202C"/>
+            </a:solidFill>
+            <a:prstDash val="solid"/>
+          </a:ln>
+        </p:spPr>
+      </p:sp>
+      <p:sp>
+        <p:nvSpPr>
+          <p:cNvPr id="23" name="Text 21"/>
+          <p:cNvSpPr/>
+          <p:nvPr/>
+        </p:nvSpPr>
+        <p:spPr>
+          <a:xfrm>
+            <a:off x="658368" y="4828032"/>
+            <a:ext cx="6135624" cy="274320"/>
+          </a:xfrm>
+          <a:prstGeom prst="rect">
+            <a:avLst/>
+          </a:prstGeom>
+          <a:noFill/>
+          <a:ln/>
+        </p:spPr>
+        <p:txBody>
+          <a:bodyPr wrap="square" lIns="0" tIns="0" rIns="0" bIns="0" rtlCol="0" anchor="ctr"/>
+          <a:lstStyle/>
+          <a:p>
+            <a:pPr indent="0" marL="0">
+              <a:buNone/>
+            </a:pPr>
+            <a:r>
+              <a:rPr lang="en-US" sz="1200" b="1" spc="200" kern="0" dirty="0">
+                <a:solidFill>
+                  <a:srgbClr val="DCC3CB"/>
+                </a:solidFill>
+                <a:latin typeface="Arial" pitchFamily="34" charset="0"/>
+                <a:ea typeface="Arial" pitchFamily="34" charset="-122"/>
+                <a:cs typeface="Arial" pitchFamily="34" charset="-120"/>
+              </a:rPr>
+              <a:t>HOW IT'S WIRED</a:t>
+            </a:r>
+            <a:endParaRPr lang="en-US" sz="1200" dirty="0"/>
+          </a:p>
+        </p:txBody>
+      </p:sp>
+      <p:sp>
+        <p:nvSpPr>
+          <p:cNvPr id="24" name="Text 22"/>
+          <p:cNvSpPr/>
+          <p:nvPr/>
+        </p:nvSpPr>
+        <p:spPr>
+          <a:xfrm>
+            <a:off x="658368" y="5157216"/>
+            <a:ext cx="6135624" cy="969264"/>
+          </a:xfrm>
+          <a:prstGeom prst="rect">
+            <a:avLst/>
+          </a:prstGeom>
+          <a:noFill/>
+          <a:ln/>
+        </p:spPr>
+        <p:txBody>
+          <a:bodyPr wrap="square" lIns="0" tIns="0" rIns="0" bIns="0" rtlCol="0" anchor="t"/>
+          <a:lstStyle/>
+          <a:p>
+            <a:pPr marL="342900" indent="-342900">
+              <a:lnSpc>
+                <a:spcPct val="102000"/>
+              </a:lnSpc>
+              <a:spcAft>
+                <a:spcPts val="600"/>
+              </a:spcAft>
+              <a:buSzPct val="100000"/>
+              <a:buFont typeface="+mj-lt"/>
+              <a:buAutoNum type="arabicPeriod" startAt="1"/>
+            </a:pPr>
+            <a:r>
+              <a:rPr lang="en-US" sz="1200" dirty="0">
+                <a:solidFill>
+                  <a:srgbClr val="F9F3F5"/>
+                </a:solidFill>
+                <a:latin typeface="Arial" pitchFamily="34" charset="0"/>
+                <a:ea typeface="Arial" pitchFamily="34" charset="-122"/>
+                <a:cs typeface="Arial" pitchFamily="34" charset="-120"/>
+              </a:rPr>
+              <a:t>A unique UTM deep-link &amp; Disney+ promo code per episode — credit is unambiguous.</a:t>
+            </a:r>
+            <a:endParaRPr lang="en-US" sz="1200" dirty="0"/>
+          </a:p>
+          <a:p>
+            <a:pPr marL="342900" indent="-342900">
+              <a:lnSpc>
+                <a:spcPct val="102000"/>
+              </a:lnSpc>
+              <a:spcAft>
+                <a:spcPts val="600"/>
+              </a:spcAft>
+              <a:buSzPct val="100000"/>
+              <a:buFont typeface="+mj-lt"/>
+              <a:buAutoNum type="arabicPeriod" startAt="1"/>
+            </a:pPr>
+            <a:r>
+              <a:rPr lang="en-US" sz="1200" dirty="0">
+                <a:solidFill>
+                  <a:srgbClr val="F9F3F5"/>
+                </a:solidFill>
+                <a:latin typeface="Arial" pitchFamily="34" charset="0"/>
+                <a:ea typeface="Arial" pitchFamily="34" charset="-122"/>
+                <a:cs typeface="Arial" pitchFamily="34" charset="-120"/>
+              </a:rPr>
+              <a:t>A giveaway landing page that gates entry behind the sign-up path.</a:t>
+            </a:r>
+            <a:endParaRPr lang="en-US" sz="1200" dirty="0"/>
+          </a:p>
+          <a:p>
+            <a:pPr marL="342900" indent="-342900">
+              <a:lnSpc>
+                <a:spcPct val="102000"/>
+              </a:lnSpc>
+              <a:buSzPct val="100000"/>
+              <a:buFont typeface="+mj-lt"/>
+              <a:buAutoNum type="arabicPeriod" startAt="1"/>
+            </a:pPr>
+            <a:r>
+              <a:rPr lang="en-US" sz="1200" dirty="0">
+                <a:solidFill>
+                  <a:srgbClr val="F9F3F5"/>
+                </a:solidFill>
+                <a:latin typeface="Arial" pitchFamily="34" charset="0"/>
+                <a:ea typeface="Arial" pitchFamily="34" charset="-122"/>
+                <a:cs typeface="Arial" pitchFamily="34" charset="-120"/>
+              </a:rPr>
+              <a:t>A fortnightly report to Disney+ — reach, clicks, sign-ups, CPA. Nothing behind the curtain.</a:t>
+            </a:r>
+            <a:endParaRPr lang="en-US" sz="1200" dirty="0"/>
+          </a:p>
+        </p:txBody>
+      </p:sp>
+      <p:sp>
+        <p:nvSpPr>
+          <p:cNvPr id="25" name="Shape 23"/>
+          <p:cNvSpPr/>
+          <p:nvPr/>
+        </p:nvSpPr>
+        <p:spPr>
+          <a:xfrm>
+            <a:off x="7269480" y="4681728"/>
+            <a:ext cx="4462272" cy="1572768"/>
+          </a:xfrm>
+          <a:prstGeom prst="roundRect">
+            <a:avLst>
+              <a:gd name="adj" fmla="val 5233"/>
+            </a:avLst>
+          </a:prstGeom>
+          <a:solidFill>
+            <a:srgbClr val="2A111B"/>
+          </a:solidFill>
+          <a:ln w="12700">
+            <a:solidFill>
+              <a:srgbClr val="2E5B8C"/>
+            </a:solidFill>
+            <a:prstDash val="solid"/>
+          </a:ln>
+        </p:spPr>
+      </p:sp>
+      <p:sp>
+        <p:nvSpPr>
+          <p:cNvPr id="26" name="Text 24"/>
+          <p:cNvSpPr/>
+          <p:nvPr/>
+        </p:nvSpPr>
+        <p:spPr>
+          <a:xfrm>
+            <a:off x="7470648" y="4846320"/>
+            <a:ext cx="4059936" cy="274320"/>
+          </a:xfrm>
+          <a:prstGeom prst="rect">
+            <a:avLst/>
+          </a:prstGeom>
+          <a:noFill/>
+          <a:ln/>
+        </p:spPr>
+        <p:txBody>
+          <a:bodyPr wrap="square" lIns="0" tIns="0" rIns="0" bIns="0" rtlCol="0" anchor="ctr"/>
+          <a:lstStyle/>
+          <a:p>
+            <a:pPr indent="0" marL="0">
+              <a:buNone/>
+            </a:pPr>
+            <a:r>
+              <a:rPr lang="en-US" sz="1050" b="1" spc="150" kern="0" dirty="0">
+                <a:solidFill>
+                  <a:srgbClr val="5AA7FF"/>
+                </a:solidFill>
+                <a:latin typeface="Arial" pitchFamily="34" charset="0"/>
+                <a:ea typeface="Arial" pitchFamily="34" charset="-122"/>
+                <a:cs typeface="Arial" pitchFamily="34" charset="-120"/>
+              </a:rPr>
+              <a:t>THE UNLOCK — ALREADY LIVE</a:t>
+            </a:r>
+            <a:endParaRPr lang="en-US" sz="1050" dirty="0"/>
+          </a:p>
+        </p:txBody>
+      </p:sp>
+      <p:sp>
+        <p:nvSpPr>
+          <p:cNvPr id="27" name="Text 25"/>
+          <p:cNvSpPr/>
+          <p:nvPr/>
+        </p:nvSpPr>
+        <p:spPr>
+          <a:xfrm>
+            <a:off x="7470648" y="5212080"/>
+            <a:ext cx="4059936" cy="914400"/>
+          </a:xfrm>
+          <a:prstGeom prst="rect">
+            <a:avLst/>
+          </a:prstGeom>
+          <a:noFill/>
+          <a:ln/>
+        </p:spPr>
+        <p:txBody>
+          <a:bodyPr wrap="square" lIns="0" tIns="0" rIns="0" bIns="0" rtlCol="0" anchor="t"/>
+          <a:lstStyle/>
+          <a:p>
+            <a:pPr indent="0" marL="0">
+              <a:lnSpc>
+                <a:spcPct val="106000"/>
+              </a:lnSpc>
+              <a:buNone/>
+            </a:pPr>
+            <a:r>
+              <a:rPr lang="en-US" sz="1300" dirty="0">
+                <a:solidFill>
+                  <a:srgbClr val="F9F3F5"/>
+                </a:solidFill>
+                <a:latin typeface="Arial" pitchFamily="34" charset="0"/>
+                <a:ea typeface="Arial" pitchFamily="34" charset="-122"/>
+                <a:cs typeface="Arial" pitchFamily="34" charset="-120"/>
+              </a:rPr>
+              <a:t>Every </a:t>
+            </a:r>
+            <a:pPr indent="0" marL="0">
+              <a:lnSpc>
+                <a:spcPct val="106000"/>
+              </a:lnSpc>
+              <a:buNone/>
+            </a:pPr>
+            <a:r>
+              <a:rPr lang="en-US" sz="1300" b="1" dirty="0">
+                <a:solidFill>
+                  <a:srgbClr val="F5294B"/>
+                </a:solidFill>
+                <a:latin typeface="Arial" pitchFamily="34" charset="0"/>
+                <a:ea typeface="Arial" pitchFamily="34" charset="-122"/>
+                <a:cs typeface="Arial" pitchFamily="34" charset="-120"/>
+              </a:rPr>
+              <a:t>“Watch on Disney+”</a:t>
+            </a:r>
+            <a:pPr indent="0" marL="0">
+              <a:lnSpc>
+                <a:spcPct val="106000"/>
+              </a:lnSpc>
+              <a:buNone/>
+            </a:pPr>
+            <a:r>
+              <a:rPr lang="en-US" sz="1300" dirty="0">
+                <a:solidFill>
+                  <a:srgbClr val="F9F3F5"/>
+                </a:solidFill>
+                <a:latin typeface="Arial" pitchFamily="34" charset="0"/>
+                <a:ea typeface="Arial" pitchFamily="34" charset="-122"/>
+                <a:cs typeface="Arial" pitchFamily="34" charset="-120"/>
+              </a:rPr>
+              <a:t> tap in the hub is one of these tracked links — and the hub is running today at </a:t>
+            </a:r>
+            <a:pPr indent="0" marL="0">
+              <a:lnSpc>
+                <a:spcPct val="106000"/>
+              </a:lnSpc>
+              <a:buNone/>
+            </a:pPr>
+            <a:r>
+              <a:rPr lang="en-US" sz="1300" b="1" dirty="0">
+                <a:solidFill>
+                  <a:srgbClr val="5AA7FF"/>
+                </a:solidFill>
+                <a:latin typeface="Arial" pitchFamily="34" charset="0"/>
+                <a:ea typeface="Arial" pitchFamily="34" charset="-122"/>
+                <a:cs typeface="Arial" pitchFamily="34" charset="-120"/>
+              </a:rPr>
+              <a:t>armchair-nfl.vercel.app</a:t>
+            </a:r>
+            <a:pPr indent="0" marL="0">
+              <a:lnSpc>
+                <a:spcPct val="106000"/>
+              </a:lnSpc>
+              <a:buNone/>
+            </a:pPr>
+            <a:r>
+              <a:rPr lang="en-US" sz="1300" dirty="0">
+                <a:solidFill>
+                  <a:srgbClr val="F9F3F5"/>
+                </a:solidFill>
+                <a:latin typeface="Arial" pitchFamily="34" charset="0"/>
+                <a:ea typeface="Arial" pitchFamily="34" charset="-122"/>
+                <a:cs typeface="Arial" pitchFamily="34" charset="-120"/>
+              </a:rPr>
+              <a:t>. Product and measurement are the same system.</a:t>
+            </a:r>
+            <a:endParaRPr lang="en-US" sz="1300" dirty="0"/>
+          </a:p>
+        </p:txBody>
+      </p:sp>
+      <p:sp>
+        <p:nvSpPr>
+          <p:cNvPr id="28" name="Text 26"/>
+          <p:cNvSpPr/>
+          <p:nvPr/>
+        </p:nvSpPr>
+        <p:spPr>
+          <a:xfrm>
+            <a:off x="457200" y="6419088"/>
+            <a:ext cx="11274552" cy="320040"/>
+          </a:xfrm>
+          <a:prstGeom prst="rect">
+            <a:avLst/>
+          </a:prstGeom>
+          <a:noFill/>
+          <a:ln/>
+        </p:spPr>
+        <p:txBody>
+          <a:bodyPr wrap="square" lIns="0" tIns="0" rIns="0" bIns="0" rtlCol="0" anchor="t"/>
+          <a:lstStyle/>
+          <a:p>
+            <a:pPr indent="0" marL="0">
+              <a:buNone/>
+            </a:pPr>
+            <a:r>
+              <a:rPr lang="en-US" sz="950" dirty="0">
+                <a:solidFill>
+                  <a:srgbClr val="A57E8B"/>
+                </a:solidFill>
+                <a:latin typeface="Arial" pitchFamily="34" charset="0"/>
+                <a:ea typeface="Arial" pitchFamily="34" charset="-122"/>
+                <a:cs typeface="Arial" pitchFamily="34" charset="-120"/>
+              </a:rPr>
+              <a:t>Live platform: armchair-nfl.vercel.app — palette &amp; type match, so the pitch reads as one system. Concept for pitch purposes; not affiliated with the NFL, ESPN or Disney+.</a:t>
+            </a:r>
+            <a:endParaRPr lang="en-US" sz="950" dirty="0"/>
+          </a:p>
+        </p:txBody>
+      </p:sp>
+    </p:spTree>
+  </p:cSld>
+  <p:clrMapOvr>
+    <a:masterClrMapping/>
+  </p:clrMapOvr>
+</p:sld>
+</file>
+
+<file path=ppt/slides/slide4.xml><?xml version="1.0" encoding="utf-8"?>
+<p:sld xmlns:a="http://schemas.openxmlformats.org/drawingml/2006/main" xmlns:r="http://schemas.openxmlformats.org/officeDocument/2006/relationships" xmlns:p="http://schemas.openxmlformats.org/presentationml/2006/main">
+  <p:cSld name="Slide 4">
     <p:bg>
       <p:bgPr>
         <a:solidFill>

</xml_diff>